<commit_message>
Docs: deck with real website screenshots (terminal, mining, evolution lab, backtest, report card, paper trading); handout markers updated
Co-Authored-By: Claude Fable 5.1 <noreply@anthropic.com>
</commit_message>
<xml_diff>
--- a/docs/lecture/因子挖掘-15分钟.pptx
+++ b/docs/lecture/因子挖掘-15分钟.pptx
@@ -1018,1419 +1018,6 @@
 </c:chartSpace>
 </file>
 
-<file path=ppt/charts/chart3.xml><?xml version="1.0" encoding="utf-8"?>
-<c:chartSpace xmlns:c="http://schemas.openxmlformats.org/drawingml/2006/chart" xmlns:a="http://schemas.openxmlformats.org/drawingml/2006/main" xmlns:r="http://schemas.openxmlformats.org/officeDocument/2006/relationships">
-  <c:date1904 val="0"/>
-  <c:roundedCorners val="1"/>
-  <c:chart>
-    <c:title>
-      <c:tx>
-        <c:rich>
-          <a:bodyPr/>
-          <a:lstStyle/>
-          <a:p>
-            <a:pPr>
-              <a:defRPr sz="1000" b="0" i="0" u="none" strike="noStrike">
-                <a:solidFill>
-                  <a:srgbClr val="13213A"/>
-                </a:solidFill>
-                <a:latin typeface="Microsoft YaHei"/>
-              </a:defRPr>
-            </a:pPr>
-            <a:r>
-              <a:rPr sz="1000" b="0" i="0" u="none" strike="noStrike">
-                <a:solidFill>
-                  <a:srgbClr val="13213A"/>
-                </a:solidFill>
-                <a:latin typeface="Microsoft YaHei"/>
-              </a:rPr>
-              <a:t>示意：IC 0.03 的因子做成 Top-5 组合，两年 +38% vs 基准 +41%</a:t>
-            </a:r>
-          </a:p>
-        </c:rich>
-      </c:tx>
-      <c:layout/>
-      <c:overlay val="0"/>
-    </c:title>
-    <c:autoTitleDeleted val="0"/>
-    <c:plotArea>
-      <c:layout/>
-      <c:lineChart>
-        <c:varyColors val="0"/>
-        <c:ser>
-          <c:idx val="0"/>
-          <c:order val="0"/>
-          <c:tx>
-            <c:strRef>
-              <c:f>Sheet1!$B$1</c:f>
-              <c:strCache>
-                <c:ptCount val="1"/>
-                <c:pt idx="0">
-                  <c:v>因子组合（Top-5）</c:v>
-                </c:pt>
-              </c:strCache>
-            </c:strRef>
-          </c:tx>
-          <c:spPr>
-            <a:solidFill>
-              <a:srgbClr val="0FA8C9"/>
-            </a:solidFill>
-            <a:ln w="22860" cap="flat">
-              <a:solidFill>
-                <a:srgbClr val="0FA8C9"/>
-              </a:solidFill>
-              <a:prstDash val="solid"/>
-              <a:round/>
-            </a:ln>
-            <a:effectLst/>
-          </c:spPr>
-          <c:invertIfNegative val="0"/>
-          <c:dLbls>
-            <c:numFmt formatCode="#,##0" sourceLinked="0"/>
-            <c:txPr>
-              <a:bodyPr/>
-              <a:lstStyle/>
-              <a:p>
-                <a:pPr>
-                  <a:defRPr b="0" i="0" strike="noStrike" sz="1200" u="none">
-                    <a:solidFill>
-                      <a:srgbClr val="000000"/>
-                    </a:solidFill>
-                    <a:latin typeface="Arial"/>
-                  </a:defRPr>
-                </a:pPr>
-              </a:p>
-            </c:txPr>
-            <c:showLegendKey val="0"/>
-            <c:showVal val="0"/>
-            <c:showCatName val="0"/>
-            <c:showSerName val="0"/>
-            <c:showPercent val="0"/>
-            <c:showBubbleSize val="0"/>
-            <c:showLeaderLines val="0"/>
-          </c:dLbls>
-          <c:marker>
-            <c:symbol val="none"/>
-            <c:size val="6"/>
-            <c:spPr>
-              <a:solidFill>
-                <a:srgbClr val="0FA8C9"/>
-              </a:solidFill>
-              <a:ln w="9525" cap="flat">
-                <a:solidFill>
-                  <a:srgbClr val="0FA8C9"/>
-                </a:solidFill>
-                <a:prstDash val="solid"/>
-                <a:round/>
-              </a:ln>
-              <a:effectLst/>
-            </c:spPr>
-          </c:marker>
-          <c:cat>
-            <c:multiLvlStrRef>
-              <c:f>Sheet1!$A$2:$A$61</c:f>
-              <c:multiLvlStrCache>
-                <c:ptCount val="60"/>
-                <c:lvl>
-                  <c:pt idx="0">
-                    <c:v>1</c:v>
-                  </c:pt>
-                  <c:pt idx="1">
-                    <c:v>2</c:v>
-                  </c:pt>
-                  <c:pt idx="2">
-                    <c:v>3</c:v>
-                  </c:pt>
-                  <c:pt idx="3">
-                    <c:v>4</c:v>
-                  </c:pt>
-                  <c:pt idx="4">
-                    <c:v>5</c:v>
-                  </c:pt>
-                  <c:pt idx="5">
-                    <c:v>6</c:v>
-                  </c:pt>
-                  <c:pt idx="6">
-                    <c:v>7</c:v>
-                  </c:pt>
-                  <c:pt idx="7">
-                    <c:v>8</c:v>
-                  </c:pt>
-                  <c:pt idx="8">
-                    <c:v>9</c:v>
-                  </c:pt>
-                  <c:pt idx="9">
-                    <c:v>10</c:v>
-                  </c:pt>
-                  <c:pt idx="10">
-                    <c:v>11</c:v>
-                  </c:pt>
-                  <c:pt idx="11">
-                    <c:v>12</c:v>
-                  </c:pt>
-                  <c:pt idx="12">
-                    <c:v>13</c:v>
-                  </c:pt>
-                  <c:pt idx="13">
-                    <c:v>14</c:v>
-                  </c:pt>
-                  <c:pt idx="14">
-                    <c:v>15</c:v>
-                  </c:pt>
-                  <c:pt idx="15">
-                    <c:v>16</c:v>
-                  </c:pt>
-                  <c:pt idx="16">
-                    <c:v>17</c:v>
-                  </c:pt>
-                  <c:pt idx="17">
-                    <c:v>18</c:v>
-                  </c:pt>
-                  <c:pt idx="18">
-                    <c:v>19</c:v>
-                  </c:pt>
-                  <c:pt idx="19">
-                    <c:v>20</c:v>
-                  </c:pt>
-                  <c:pt idx="20">
-                    <c:v>21</c:v>
-                  </c:pt>
-                  <c:pt idx="21">
-                    <c:v>22</c:v>
-                  </c:pt>
-                  <c:pt idx="22">
-                    <c:v>23</c:v>
-                  </c:pt>
-                  <c:pt idx="23">
-                    <c:v>24</c:v>
-                  </c:pt>
-                  <c:pt idx="24">
-                    <c:v>25</c:v>
-                  </c:pt>
-                  <c:pt idx="25">
-                    <c:v>26</c:v>
-                  </c:pt>
-                  <c:pt idx="26">
-                    <c:v>27</c:v>
-                  </c:pt>
-                  <c:pt idx="27">
-                    <c:v>28</c:v>
-                  </c:pt>
-                  <c:pt idx="28">
-                    <c:v>29</c:v>
-                  </c:pt>
-                  <c:pt idx="29">
-                    <c:v>30</c:v>
-                  </c:pt>
-                  <c:pt idx="30">
-                    <c:v>31</c:v>
-                  </c:pt>
-                  <c:pt idx="31">
-                    <c:v>32</c:v>
-                  </c:pt>
-                  <c:pt idx="32">
-                    <c:v>33</c:v>
-                  </c:pt>
-                  <c:pt idx="33">
-                    <c:v>34</c:v>
-                  </c:pt>
-                  <c:pt idx="34">
-                    <c:v>35</c:v>
-                  </c:pt>
-                  <c:pt idx="35">
-                    <c:v>36</c:v>
-                  </c:pt>
-                  <c:pt idx="36">
-                    <c:v>37</c:v>
-                  </c:pt>
-                  <c:pt idx="37">
-                    <c:v>38</c:v>
-                  </c:pt>
-                  <c:pt idx="38">
-                    <c:v>39</c:v>
-                  </c:pt>
-                  <c:pt idx="39">
-                    <c:v>40</c:v>
-                  </c:pt>
-                  <c:pt idx="40">
-                    <c:v>41</c:v>
-                  </c:pt>
-                  <c:pt idx="41">
-                    <c:v>42</c:v>
-                  </c:pt>
-                  <c:pt idx="42">
-                    <c:v>43</c:v>
-                  </c:pt>
-                  <c:pt idx="43">
-                    <c:v>44</c:v>
-                  </c:pt>
-                  <c:pt idx="44">
-                    <c:v>45</c:v>
-                  </c:pt>
-                  <c:pt idx="45">
-                    <c:v>46</c:v>
-                  </c:pt>
-                  <c:pt idx="46">
-                    <c:v>47</c:v>
-                  </c:pt>
-                  <c:pt idx="47">
-                    <c:v>48</c:v>
-                  </c:pt>
-                  <c:pt idx="48">
-                    <c:v>49</c:v>
-                  </c:pt>
-                  <c:pt idx="49">
-                    <c:v>50</c:v>
-                  </c:pt>
-                  <c:pt idx="50">
-                    <c:v>51</c:v>
-                  </c:pt>
-                  <c:pt idx="51">
-                    <c:v>52</c:v>
-                  </c:pt>
-                  <c:pt idx="52">
-                    <c:v>53</c:v>
-                  </c:pt>
-                  <c:pt idx="53">
-                    <c:v>54</c:v>
-                  </c:pt>
-                  <c:pt idx="54">
-                    <c:v>55</c:v>
-                  </c:pt>
-                  <c:pt idx="55">
-                    <c:v>56</c:v>
-                  </c:pt>
-                  <c:pt idx="56">
-                    <c:v>57</c:v>
-                  </c:pt>
-                  <c:pt idx="57">
-                    <c:v>58</c:v>
-                  </c:pt>
-                  <c:pt idx="58">
-                    <c:v>59</c:v>
-                  </c:pt>
-                  <c:pt idx="59">
-                    <c:v>60</c:v>
-                  </c:pt>
-                </c:lvl>
-              </c:multiLvlStrCache>
-            </c:multiLvlStrRef>
-          </c:cat>
-          <c:val>
-            <c:numRef>
-              <c:f>Sheet1!$B$2:$B$61</c:f>
-              <c:numCache>
-                <c:formatCode>General</c:formatCode>
-                <c:ptCount val="60"/>
-                <c:pt idx="0">
-                  <c:v>100.3</c:v>
-                </c:pt>
-                <c:pt idx="1">
-                  <c:v>100.7</c:v>
-                </c:pt>
-                <c:pt idx="2">
-                  <c:v>101.2</c:v>
-                </c:pt>
-                <c:pt idx="3">
-                  <c:v>101.8</c:v>
-                </c:pt>
-                <c:pt idx="4">
-                  <c:v>102.5</c:v>
-                </c:pt>
-                <c:pt idx="5">
-                  <c:v>103.2</c:v>
-                </c:pt>
-                <c:pt idx="6">
-                  <c:v>104</c:v>
-                </c:pt>
-                <c:pt idx="7">
-                  <c:v>104.9</c:v>
-                </c:pt>
-                <c:pt idx="8">
-                  <c:v>105.8</c:v>
-                </c:pt>
-                <c:pt idx="9">
-                  <c:v>106.6</c:v>
-                </c:pt>
-                <c:pt idx="10">
-                  <c:v>107.5</c:v>
-                </c:pt>
-                <c:pt idx="11">
-                  <c:v>108.2</c:v>
-                </c:pt>
-                <c:pt idx="12">
-                  <c:v>108.9</c:v>
-                </c:pt>
-                <c:pt idx="13">
-                  <c:v>109.5</c:v>
-                </c:pt>
-                <c:pt idx="14">
-                  <c:v>110.1</c:v>
-                </c:pt>
-                <c:pt idx="15">
-                  <c:v>110.5</c:v>
-                </c:pt>
-                <c:pt idx="16">
-                  <c:v>110.7</c:v>
-                </c:pt>
-                <c:pt idx="17">
-                  <c:v>110.9</c:v>
-                </c:pt>
-                <c:pt idx="18">
-                  <c:v>110.9</c:v>
-                </c:pt>
-                <c:pt idx="19">
-                  <c:v>110.9</c:v>
-                </c:pt>
-                <c:pt idx="20">
-                  <c:v>110.7</c:v>
-                </c:pt>
-                <c:pt idx="21">
-                  <c:v>110.5</c:v>
-                </c:pt>
-                <c:pt idx="22">
-                  <c:v>110.2</c:v>
-                </c:pt>
-                <c:pt idx="23">
-                  <c:v>109.9</c:v>
-                </c:pt>
-                <c:pt idx="24">
-                  <c:v>109.6</c:v>
-                </c:pt>
-                <c:pt idx="25">
-                  <c:v>109.4</c:v>
-                </c:pt>
-                <c:pt idx="26">
-                  <c:v>109.1</c:v>
-                </c:pt>
-                <c:pt idx="27">
-                  <c:v>109</c:v>
-                </c:pt>
-                <c:pt idx="28">
-                  <c:v>108.9</c:v>
-                </c:pt>
-                <c:pt idx="29">
-                  <c:v>108.9</c:v>
-                </c:pt>
-                <c:pt idx="30">
-                  <c:v>109.1</c:v>
-                </c:pt>
-                <c:pt idx="31">
-                  <c:v>109.3</c:v>
-                </c:pt>
-                <c:pt idx="32">
-                  <c:v>109.7</c:v>
-                </c:pt>
-                <c:pt idx="33">
-                  <c:v>110.2</c:v>
-                </c:pt>
-                <c:pt idx="34">
-                  <c:v>110.8</c:v>
-                </c:pt>
-                <c:pt idx="35">
-                  <c:v>111.5</c:v>
-                </c:pt>
-                <c:pt idx="36">
-                  <c:v>112.3</c:v>
-                </c:pt>
-                <c:pt idx="37">
-                  <c:v>113.2</c:v>
-                </c:pt>
-                <c:pt idx="38">
-                  <c:v>114.1</c:v>
-                </c:pt>
-                <c:pt idx="39">
-                  <c:v>115</c:v>
-                </c:pt>
-                <c:pt idx="40">
-                  <c:v>116</c:v>
-                </c:pt>
-                <c:pt idx="41">
-                  <c:v>116.9</c:v>
-                </c:pt>
-                <c:pt idx="42">
-                  <c:v>117.8</c:v>
-                </c:pt>
-                <c:pt idx="43">
-                  <c:v>118.6</c:v>
-                </c:pt>
-                <c:pt idx="44">
-                  <c:v>119.3</c:v>
-                </c:pt>
-                <c:pt idx="45">
-                  <c:v>119.9</c:v>
-                </c:pt>
-                <c:pt idx="46">
-                  <c:v>120.4</c:v>
-                </c:pt>
-                <c:pt idx="47">
-                  <c:v>120.8</c:v>
-                </c:pt>
-                <c:pt idx="48">
-                  <c:v>121</c:v>
-                </c:pt>
-                <c:pt idx="49">
-                  <c:v>121.1</c:v>
-                </c:pt>
-                <c:pt idx="50">
-                  <c:v>121</c:v>
-                </c:pt>
-                <c:pt idx="51">
-                  <c:v>120.9</c:v>
-                </c:pt>
-                <c:pt idx="52">
-                  <c:v>120.7</c:v>
-                </c:pt>
-                <c:pt idx="53">
-                  <c:v>120.4</c:v>
-                </c:pt>
-                <c:pt idx="54">
-                  <c:v>120.1</c:v>
-                </c:pt>
-                <c:pt idx="55">
-                  <c:v>119.8</c:v>
-                </c:pt>
-                <c:pt idx="56">
-                  <c:v>119.5</c:v>
-                </c:pt>
-                <c:pt idx="57">
-                  <c:v>119.2</c:v>
-                </c:pt>
-                <c:pt idx="58">
-                  <c:v>119</c:v>
-                </c:pt>
-                <c:pt idx="59">
-                  <c:v>118.9</c:v>
-                </c:pt>
-              </c:numCache>
-            </c:numRef>
-          </c:val>
-          <c:smooth val="0"/>
-        </c:ser>
-        <c:ser>
-          <c:idx val="1"/>
-          <c:order val="1"/>
-          <c:tx>
-            <c:strRef>
-              <c:f>Sheet1!$C$1</c:f>
-              <c:strCache>
-                <c:ptCount val="1"/>
-                <c:pt idx="0">
-                  <c:v>等权买入持有（基准）</c:v>
-                </c:pt>
-              </c:strCache>
-            </c:strRef>
-          </c:tx>
-          <c:spPr>
-            <a:solidFill>
-              <a:srgbClr val="6B7A90"/>
-            </a:solidFill>
-            <a:ln w="22860" cap="flat">
-              <a:solidFill>
-                <a:srgbClr val="6B7A90"/>
-              </a:solidFill>
-              <a:prstDash val="solid"/>
-              <a:round/>
-            </a:ln>
-            <a:effectLst/>
-          </c:spPr>
-          <c:invertIfNegative val="0"/>
-          <c:dLbls>
-            <c:numFmt formatCode="#,##0" sourceLinked="0"/>
-            <c:txPr>
-              <a:bodyPr/>
-              <a:lstStyle/>
-              <a:p>
-                <a:pPr>
-                  <a:defRPr b="0" i="0" strike="noStrike" sz="1200" u="none">
-                    <a:solidFill>
-                      <a:srgbClr val="000000"/>
-                    </a:solidFill>
-                    <a:latin typeface="Arial"/>
-                  </a:defRPr>
-                </a:pPr>
-              </a:p>
-            </c:txPr>
-            <c:showLegendKey val="0"/>
-            <c:showVal val="0"/>
-            <c:showCatName val="0"/>
-            <c:showSerName val="0"/>
-            <c:showPercent val="0"/>
-            <c:showBubbleSize val="0"/>
-            <c:showLeaderLines val="0"/>
-          </c:dLbls>
-          <c:marker>
-            <c:symbol val="none"/>
-            <c:size val="6"/>
-            <c:spPr>
-              <a:solidFill>
-                <a:srgbClr val="6B7A90"/>
-              </a:solidFill>
-              <a:ln w="9525" cap="flat">
-                <a:solidFill>
-                  <a:srgbClr val="6B7A90"/>
-                </a:solidFill>
-                <a:prstDash val="solid"/>
-                <a:round/>
-              </a:ln>
-              <a:effectLst/>
-            </c:spPr>
-          </c:marker>
-          <c:cat>
-            <c:multiLvlStrRef>
-              <c:f>Sheet1!$A$2:$A$61</c:f>
-              <c:multiLvlStrCache>
-                <c:ptCount val="60"/>
-                <c:lvl>
-                  <c:pt idx="0">
-                    <c:v>1</c:v>
-                  </c:pt>
-                  <c:pt idx="1">
-                    <c:v>2</c:v>
-                  </c:pt>
-                  <c:pt idx="2">
-                    <c:v>3</c:v>
-                  </c:pt>
-                  <c:pt idx="3">
-                    <c:v>4</c:v>
-                  </c:pt>
-                  <c:pt idx="4">
-                    <c:v>5</c:v>
-                  </c:pt>
-                  <c:pt idx="5">
-                    <c:v>6</c:v>
-                  </c:pt>
-                  <c:pt idx="6">
-                    <c:v>7</c:v>
-                  </c:pt>
-                  <c:pt idx="7">
-                    <c:v>8</c:v>
-                  </c:pt>
-                  <c:pt idx="8">
-                    <c:v>9</c:v>
-                  </c:pt>
-                  <c:pt idx="9">
-                    <c:v>10</c:v>
-                  </c:pt>
-                  <c:pt idx="10">
-                    <c:v>11</c:v>
-                  </c:pt>
-                  <c:pt idx="11">
-                    <c:v>12</c:v>
-                  </c:pt>
-                  <c:pt idx="12">
-                    <c:v>13</c:v>
-                  </c:pt>
-                  <c:pt idx="13">
-                    <c:v>14</c:v>
-                  </c:pt>
-                  <c:pt idx="14">
-                    <c:v>15</c:v>
-                  </c:pt>
-                  <c:pt idx="15">
-                    <c:v>16</c:v>
-                  </c:pt>
-                  <c:pt idx="16">
-                    <c:v>17</c:v>
-                  </c:pt>
-                  <c:pt idx="17">
-                    <c:v>18</c:v>
-                  </c:pt>
-                  <c:pt idx="18">
-                    <c:v>19</c:v>
-                  </c:pt>
-                  <c:pt idx="19">
-                    <c:v>20</c:v>
-                  </c:pt>
-                  <c:pt idx="20">
-                    <c:v>21</c:v>
-                  </c:pt>
-                  <c:pt idx="21">
-                    <c:v>22</c:v>
-                  </c:pt>
-                  <c:pt idx="22">
-                    <c:v>23</c:v>
-                  </c:pt>
-                  <c:pt idx="23">
-                    <c:v>24</c:v>
-                  </c:pt>
-                  <c:pt idx="24">
-                    <c:v>25</c:v>
-                  </c:pt>
-                  <c:pt idx="25">
-                    <c:v>26</c:v>
-                  </c:pt>
-                  <c:pt idx="26">
-                    <c:v>27</c:v>
-                  </c:pt>
-                  <c:pt idx="27">
-                    <c:v>28</c:v>
-                  </c:pt>
-                  <c:pt idx="28">
-                    <c:v>29</c:v>
-                  </c:pt>
-                  <c:pt idx="29">
-                    <c:v>30</c:v>
-                  </c:pt>
-                  <c:pt idx="30">
-                    <c:v>31</c:v>
-                  </c:pt>
-                  <c:pt idx="31">
-                    <c:v>32</c:v>
-                  </c:pt>
-                  <c:pt idx="32">
-                    <c:v>33</c:v>
-                  </c:pt>
-                  <c:pt idx="33">
-                    <c:v>34</c:v>
-                  </c:pt>
-                  <c:pt idx="34">
-                    <c:v>35</c:v>
-                  </c:pt>
-                  <c:pt idx="35">
-                    <c:v>36</c:v>
-                  </c:pt>
-                  <c:pt idx="36">
-                    <c:v>37</c:v>
-                  </c:pt>
-                  <c:pt idx="37">
-                    <c:v>38</c:v>
-                  </c:pt>
-                  <c:pt idx="38">
-                    <c:v>39</c:v>
-                  </c:pt>
-                  <c:pt idx="39">
-                    <c:v>40</c:v>
-                  </c:pt>
-                  <c:pt idx="40">
-                    <c:v>41</c:v>
-                  </c:pt>
-                  <c:pt idx="41">
-                    <c:v>42</c:v>
-                  </c:pt>
-                  <c:pt idx="42">
-                    <c:v>43</c:v>
-                  </c:pt>
-                  <c:pt idx="43">
-                    <c:v>44</c:v>
-                  </c:pt>
-                  <c:pt idx="44">
-                    <c:v>45</c:v>
-                  </c:pt>
-                  <c:pt idx="45">
-                    <c:v>46</c:v>
-                  </c:pt>
-                  <c:pt idx="46">
-                    <c:v>47</c:v>
-                  </c:pt>
-                  <c:pt idx="47">
-                    <c:v>48</c:v>
-                  </c:pt>
-                  <c:pt idx="48">
-                    <c:v>49</c:v>
-                  </c:pt>
-                  <c:pt idx="49">
-                    <c:v>50</c:v>
-                  </c:pt>
-                  <c:pt idx="50">
-                    <c:v>51</c:v>
-                  </c:pt>
-                  <c:pt idx="51">
-                    <c:v>52</c:v>
-                  </c:pt>
-                  <c:pt idx="52">
-                    <c:v>53</c:v>
-                  </c:pt>
-                  <c:pt idx="53">
-                    <c:v>54</c:v>
-                  </c:pt>
-                  <c:pt idx="54">
-                    <c:v>55</c:v>
-                  </c:pt>
-                  <c:pt idx="55">
-                    <c:v>56</c:v>
-                  </c:pt>
-                  <c:pt idx="56">
-                    <c:v>57</c:v>
-                  </c:pt>
-                  <c:pt idx="57">
-                    <c:v>58</c:v>
-                  </c:pt>
-                  <c:pt idx="58">
-                    <c:v>59</c:v>
-                  </c:pt>
-                  <c:pt idx="59">
-                    <c:v>60</c:v>
-                  </c:pt>
-                </c:lvl>
-              </c:multiLvlStrCache>
-            </c:multiLvlStrRef>
-          </c:cat>
-          <c:val>
-            <c:numRef>
-              <c:f>Sheet1!$C$2:$C$61</c:f>
-              <c:numCache>
-                <c:formatCode>General</c:formatCode>
-                <c:ptCount val="60"/>
-                <c:pt idx="0">
-                  <c:v>100.7</c:v>
-                </c:pt>
-                <c:pt idx="1">
-                  <c:v>101.4</c:v>
-                </c:pt>
-                <c:pt idx="2">
-                  <c:v>102.1</c:v>
-                </c:pt>
-                <c:pt idx="3">
-                  <c:v>102.8</c:v>
-                </c:pt>
-                <c:pt idx="4">
-                  <c:v>103.5</c:v>
-                </c:pt>
-                <c:pt idx="5">
-                  <c:v>104.1</c:v>
-                </c:pt>
-                <c:pt idx="6">
-                  <c:v>104.7</c:v>
-                </c:pt>
-                <c:pt idx="7">
-                  <c:v>105.3</c:v>
-                </c:pt>
-                <c:pt idx="8">
-                  <c:v>105.8</c:v>
-                </c:pt>
-                <c:pt idx="9">
-                  <c:v>106.2</c:v>
-                </c:pt>
-                <c:pt idx="10">
-                  <c:v>106.6</c:v>
-                </c:pt>
-                <c:pt idx="11">
-                  <c:v>106.9</c:v>
-                </c:pt>
-                <c:pt idx="12">
-                  <c:v>107.2</c:v>
-                </c:pt>
-                <c:pt idx="13">
-                  <c:v>107.4</c:v>
-                </c:pt>
-                <c:pt idx="14">
-                  <c:v>107.6</c:v>
-                </c:pt>
-                <c:pt idx="15">
-                  <c:v>107.7</c:v>
-                </c:pt>
-                <c:pt idx="16">
-                  <c:v>107.7</c:v>
-                </c:pt>
-                <c:pt idx="17">
-                  <c:v>107.7</c:v>
-                </c:pt>
-                <c:pt idx="18">
-                  <c:v>107.7</c:v>
-                </c:pt>
-                <c:pt idx="19">
-                  <c:v>107.6</c:v>
-                </c:pt>
-                <c:pt idx="20">
-                  <c:v>107.6</c:v>
-                </c:pt>
-                <c:pt idx="21">
-                  <c:v>107.5</c:v>
-                </c:pt>
-                <c:pt idx="22">
-                  <c:v>107.4</c:v>
-                </c:pt>
-                <c:pt idx="23">
-                  <c:v>107.3</c:v>
-                </c:pt>
-                <c:pt idx="24">
-                  <c:v>107.2</c:v>
-                </c:pt>
-                <c:pt idx="25">
-                  <c:v>107.1</c:v>
-                </c:pt>
-                <c:pt idx="26">
-                  <c:v>107.1</c:v>
-                </c:pt>
-                <c:pt idx="27">
-                  <c:v>107.1</c:v>
-                </c:pt>
-                <c:pt idx="28">
-                  <c:v>107.2</c:v>
-                </c:pt>
-                <c:pt idx="29">
-                  <c:v>107.3</c:v>
-                </c:pt>
-                <c:pt idx="30">
-                  <c:v>107.4</c:v>
-                </c:pt>
-                <c:pt idx="31">
-                  <c:v>107.6</c:v>
-                </c:pt>
-                <c:pt idx="32">
-                  <c:v>107.9</c:v>
-                </c:pt>
-                <c:pt idx="33">
-                  <c:v>108.2</c:v>
-                </c:pt>
-                <c:pt idx="34">
-                  <c:v>108.6</c:v>
-                </c:pt>
-                <c:pt idx="35">
-                  <c:v>109.1</c:v>
-                </c:pt>
-                <c:pt idx="36">
-                  <c:v>109.6</c:v>
-                </c:pt>
-                <c:pt idx="37">
-                  <c:v>110.2</c:v>
-                </c:pt>
-                <c:pt idx="38">
-                  <c:v>110.8</c:v>
-                </c:pt>
-                <c:pt idx="39">
-                  <c:v>111.5</c:v>
-                </c:pt>
-                <c:pt idx="40">
-                  <c:v>112.2</c:v>
-                </c:pt>
-                <c:pt idx="41">
-                  <c:v>113</c:v>
-                </c:pt>
-                <c:pt idx="42">
-                  <c:v>113.8</c:v>
-                </c:pt>
-                <c:pt idx="43">
-                  <c:v>114.6</c:v>
-                </c:pt>
-                <c:pt idx="44">
-                  <c:v>115.4</c:v>
-                </c:pt>
-                <c:pt idx="45">
-                  <c:v>116.2</c:v>
-                </c:pt>
-                <c:pt idx="46">
-                  <c:v>117</c:v>
-                </c:pt>
-                <c:pt idx="47">
-                  <c:v>117.8</c:v>
-                </c:pt>
-                <c:pt idx="48">
-                  <c:v>118.6</c:v>
-                </c:pt>
-                <c:pt idx="49">
-                  <c:v>119.3</c:v>
-                </c:pt>
-                <c:pt idx="50">
-                  <c:v>120</c:v>
-                </c:pt>
-                <c:pt idx="51">
-                  <c:v>120.6</c:v>
-                </c:pt>
-                <c:pt idx="52">
-                  <c:v>121.2</c:v>
-                </c:pt>
-                <c:pt idx="53">
-                  <c:v>121.7</c:v>
-                </c:pt>
-                <c:pt idx="54">
-                  <c:v>122.1</c:v>
-                </c:pt>
-                <c:pt idx="55">
-                  <c:v>122.5</c:v>
-                </c:pt>
-                <c:pt idx="56">
-                  <c:v>122.8</c:v>
-                </c:pt>
-                <c:pt idx="57">
-                  <c:v>123.1</c:v>
-                </c:pt>
-                <c:pt idx="58">
-                  <c:v>123.2</c:v>
-                </c:pt>
-                <c:pt idx="59">
-                  <c:v>123.3</c:v>
-                </c:pt>
-              </c:numCache>
-            </c:numRef>
-          </c:val>
-          <c:smooth val="0"/>
-        </c:ser>
-        <c:dLbls>
-          <c:numFmt formatCode="#,##0" sourceLinked="0"/>
-          <c:txPr>
-            <a:bodyPr/>
-            <a:lstStyle/>
-            <a:p>
-              <a:pPr>
-                <a:defRPr b="0" i="0" strike="noStrike" sz="1200" u="none">
-                  <a:solidFill>
-                    <a:srgbClr val="000000"/>
-                  </a:solidFill>
-                  <a:latin typeface="Arial"/>
-                </a:defRPr>
-              </a:pPr>
-            </a:p>
-          </c:txPr>
-          <c:showLegendKey val="0"/>
-          <c:showVal val="0"/>
-          <c:showCatName val="0"/>
-          <c:showSerName val="0"/>
-          <c:showPercent val="0"/>
-          <c:showBubbleSize val="0"/>
-          <c:showLeaderLines val="0"/>
-        </c:dLbls>
-        <c:marker val="1"/>
-        <c:axId val="2094734554"/>
-        <c:axId val="2094734552"/>
-        <c:axId val="2094734556"/>
-      </c:lineChart>
-      <c:catAx>
-        <c:axId val="2094734554"/>
-        <c:scaling>
-          <c:orientation val="minMax"/>
-        </c:scaling>
-        <c:delete val="0"/>
-        <c:axPos val="b"/>
-        <c:numFmt formatCode="General" sourceLinked="1"/>
-        <c:majorTickMark val="out"/>
-        <c:minorTickMark val="none"/>
-        <c:tickLblPos val="low"/>
-        <c:spPr>
-          <a:ln w="12700" cap="flat">
-            <a:solidFill>
-              <a:srgbClr val="888888"/>
-            </a:solidFill>
-            <a:prstDash val="solid"/>
-            <a:round/>
-          </a:ln>
-        </c:spPr>
-        <c:txPr>
-          <a:bodyPr/>
-          <a:lstStyle/>
-          <a:p>
-            <a:pPr>
-              <a:defRPr sz="900" b="0" i="0" u="none" strike="noStrike">
-                <a:solidFill>
-                  <a:srgbClr val="6B7A90"/>
-                </a:solidFill>
-                <a:latin typeface="Arial"/>
-              </a:defRPr>
-            </a:pPr>
-            <a:endParaRPr lang="en-US"/>
-          </a:p>
-        </c:txPr>
-        <c:crossAx val="2094734552"/>
-        <c:crosses val="autoZero"/>
-        <c:auto val="1"/>
-        <c:lblAlgn val="ctr"/>
-        <c:noMultiLvlLbl val="1"/>
-        <c:tickLblSkip val="10"/>
-      </c:catAx>
-      <c:valAx>
-        <c:axId val="2094734552"/>
-        <c:scaling>
-          <c:orientation val="minMax"/>
-        </c:scaling>
-        <c:delete val="0"/>
-        <c:axPos val="l"/>
-        <c:majorGridlines>
-          <c:spPr>
-            <a:ln w="6350" cap="flat">
-              <a:solidFill>
-                <a:srgbClr val="E3ECF2"/>
-              </a:solidFill>
-              <a:prstDash val="solid"/>
-              <a:round/>
-            </a:ln>
-          </c:spPr>
-        </c:majorGridlines>
-        <c:numFmt formatCode="0" sourceLinked="0"/>
-        <c:majorTickMark val="out"/>
-        <c:minorTickMark val="none"/>
-        <c:tickLblPos val="nextTo"/>
-        <c:spPr>
-          <a:ln w="12700" cap="flat">
-            <a:solidFill>
-              <a:srgbClr val="888888"/>
-            </a:solidFill>
-            <a:prstDash val="solid"/>
-            <a:round/>
-          </a:ln>
-        </c:spPr>
-        <c:txPr>
-          <a:bodyPr/>
-          <a:lstStyle/>
-          <a:p>
-            <a:pPr>
-              <a:defRPr sz="800" b="0" i="0" u="none" strike="noStrike">
-                <a:solidFill>
-                  <a:srgbClr val="6B7A90"/>
-                </a:solidFill>
-                <a:latin typeface="Arial"/>
-              </a:defRPr>
-            </a:pPr>
-            <a:endParaRPr lang="en-US"/>
-          </a:p>
-        </c:txPr>
-        <c:crossAx val="2094734554"/>
-        <c:crosses val="autoZero"/>
-        <c:crossBetween val="between"/>
-      </c:valAx>
-      <c:spPr>
-        <a:noFill/>
-        <a:ln>
-          <a:noFill/>
-        </a:ln>
-        <a:effectLst/>
-      </c:spPr>
-    </c:plotArea>
-    <c:legend>
-      <c:legendPos val="b"/>
-      <c:overlay val="0"/>
-      <c:txPr>
-        <a:bodyPr/>
-        <a:lstStyle/>
-        <a:p>
-          <a:pPr>
-            <a:defRPr sz="900">
-              <a:solidFill>
-                <a:srgbClr val="6B7A90"/>
-              </a:solidFill>
-            </a:defRPr>
-          </a:pPr>
-          <a:endParaRPr lang="en-US"/>
-        </a:p>
-      </c:txPr>
-    </c:legend>
-    <c:plotVisOnly val="1"/>
-    <c:dispBlanksAs val="span"/>
-  </c:chart>
-  <c:spPr>
-    <a:noFill/>
-    <a:ln>
-      <a:noFill/>
-    </a:ln>
-    <a:effectLst/>
-  </c:spPr>
-  <c:externalData r:id="rId1">
-    <c:autoUpdate val="0"/>
-  </c:externalData>
-</c:chartSpace>
-</file>
-
-<file path=ppt/charts/chart4.xml><?xml version="1.0" encoding="utf-8"?>
-<c:chartSpace xmlns:c="http://schemas.openxmlformats.org/drawingml/2006/chart" xmlns:a="http://schemas.openxmlformats.org/drawingml/2006/main" xmlns:r="http://schemas.openxmlformats.org/officeDocument/2006/relationships">
-  <c:date1904 val="0"/>
-  <c:roundedCorners val="1"/>
-  <c:chart>
-    <c:title>
-      <c:tx>
-        <c:rich>
-          <a:bodyPr/>
-          <a:lstStyle/>
-          <a:p>
-            <a:pPr>
-              <a:defRPr sz="1000" b="0" i="0" u="none" strike="noStrike">
-                <a:solidFill>
-                  <a:srgbClr val="13213A"/>
-                </a:solidFill>
-                <a:latin typeface="Microsoft YaHei"/>
-              </a:defRPr>
-            </a:pPr>
-            <a:r>
-              <a:rPr sz="1000" b="0" i="0" u="none" strike="noStrike">
-                <a:solidFill>
-                  <a:srgbClr val="13213A"/>
-                </a:solidFill>
-                <a:latin typeface="Microsoft YaHei"/>
-              </a:rPr>
-              <a:t>体检报告：IC 随持有期（天）变化 —— 20 天最高</a:t>
-            </a:r>
-          </a:p>
-        </c:rich>
-      </c:tx>
-      <c:layout/>
-      <c:overlay val="0"/>
-    </c:title>
-    <c:autoTitleDeleted val="0"/>
-    <c:plotArea>
-      <c:layout/>
-      <c:lineChart>
-        <c:varyColors val="0"/>
-        <c:ser>
-          <c:idx val="0"/>
-          <c:order val="0"/>
-          <c:tx>
-            <c:strRef>
-              <c:f>Sheet1!$B$1</c:f>
-              <c:strCache>
-                <c:ptCount val="1"/>
-                <c:pt idx="0">
-                  <c:v>IC</c:v>
-                </c:pt>
-              </c:strCache>
-            </c:strRef>
-          </c:tx>
-          <c:spPr>
-            <a:solidFill>
-              <a:srgbClr val="0FA8C9"/>
-            </a:solidFill>
-            <a:ln w="22860" cap="flat">
-              <a:solidFill>
-                <a:srgbClr val="0FA8C9"/>
-              </a:solidFill>
-              <a:prstDash val="solid"/>
-              <a:round/>
-            </a:ln>
-            <a:effectLst/>
-          </c:spPr>
-          <c:invertIfNegative val="0"/>
-          <c:dLbls>
-            <c:numFmt formatCode="0.000" sourceLinked="0"/>
-            <c:txPr>
-              <a:bodyPr/>
-              <a:lstStyle/>
-              <a:p>
-                <a:pPr>
-                  <a:defRPr b="0" i="0" strike="noStrike" sz="800" u="none">
-                    <a:solidFill>
-                      <a:srgbClr val="000000"/>
-                    </a:solidFill>
-                    <a:latin typeface="Arial"/>
-                  </a:defRPr>
-                </a:pPr>
-              </a:p>
-            </c:txPr>
-            <c:dLblPos val="t"/>
-            <c:showLegendKey val="0"/>
-            <c:showVal val="1"/>
-            <c:showCatName val="0"/>
-            <c:showSerName val="0"/>
-            <c:showPercent val="0"/>
-            <c:showBubbleSize val="0"/>
-            <c:showLeaderLines val="0"/>
-          </c:dLbls>
-          <c:marker>
-            <c:symbol val="circle"/>
-            <c:size val="6"/>
-            <c:spPr>
-              <a:solidFill>
-                <a:srgbClr val="0FA8C9"/>
-              </a:solidFill>
-              <a:ln w="9525" cap="flat">
-                <a:solidFill>
-                  <a:srgbClr val="0FA8C9"/>
-                </a:solidFill>
-                <a:prstDash val="solid"/>
-                <a:round/>
-              </a:ln>
-              <a:effectLst/>
-            </c:spPr>
-          </c:marker>
-          <c:cat>
-            <c:multiLvlStrRef>
-              <c:f>Sheet1!$A$2:$A$7</c:f>
-              <c:multiLvlStrCache>
-                <c:ptCount val="6"/>
-                <c:lvl>
-                  <c:pt idx="0">
-                    <c:v>1</c:v>
-                  </c:pt>
-                  <c:pt idx="1">
-                    <c:v>3</c:v>
-                  </c:pt>
-                  <c:pt idx="2">
-                    <c:v>5</c:v>
-                  </c:pt>
-                  <c:pt idx="3">
-                    <c:v>10</c:v>
-                  </c:pt>
-                  <c:pt idx="4">
-                    <c:v>20</c:v>
-                  </c:pt>
-                  <c:pt idx="5">
-                    <c:v>40</c:v>
-                  </c:pt>
-                </c:lvl>
-              </c:multiLvlStrCache>
-            </c:multiLvlStrRef>
-          </c:cat>
-          <c:val>
-            <c:numRef>
-              <c:f>Sheet1!$B$2:$B$7</c:f>
-              <c:numCache>
-                <c:formatCode>General</c:formatCode>
-                <c:ptCount val="6"/>
-                <c:pt idx="0">
-                  <c:v>-0.004</c:v>
-                </c:pt>
-                <c:pt idx="1">
-                  <c:v>0.001</c:v>
-                </c:pt>
-                <c:pt idx="2">
-                  <c:v>0.002</c:v>
-                </c:pt>
-                <c:pt idx="3">
-                  <c:v>0.003</c:v>
-                </c:pt>
-                <c:pt idx="4">
-                  <c:v>0.007</c:v>
-                </c:pt>
-                <c:pt idx="5">
-                  <c:v>-0.018</c:v>
-                </c:pt>
-              </c:numCache>
-            </c:numRef>
-          </c:val>
-          <c:smooth val="0"/>
-        </c:ser>
-        <c:dLbls>
-          <c:numFmt formatCode="0.000" sourceLinked="0"/>
-          <c:txPr>
-            <a:bodyPr/>
-            <a:lstStyle/>
-            <a:p>
-              <a:pPr>
-                <a:defRPr b="0" i="0" strike="noStrike" sz="800" u="none">
-                  <a:solidFill>
-                    <a:srgbClr val="000000"/>
-                  </a:solidFill>
-                  <a:latin typeface="Arial"/>
-                </a:defRPr>
-              </a:pPr>
-            </a:p>
-          </c:txPr>
-          <c:dLblPos val="t"/>
-          <c:showLegendKey val="0"/>
-          <c:showVal val="1"/>
-          <c:showCatName val="0"/>
-          <c:showSerName val="0"/>
-          <c:showPercent val="0"/>
-          <c:showBubbleSize val="0"/>
-          <c:showLeaderLines val="0"/>
-        </c:dLbls>
-        <c:marker val="1"/>
-        <c:axId val="2094734554"/>
-        <c:axId val="2094734552"/>
-        <c:axId val="2094734556"/>
-      </c:lineChart>
-      <c:catAx>
-        <c:axId val="2094734554"/>
-        <c:scaling>
-          <c:orientation val="minMax"/>
-        </c:scaling>
-        <c:delete val="0"/>
-        <c:axPos val="b"/>
-        <c:numFmt formatCode="General" sourceLinked="1"/>
-        <c:majorTickMark val="out"/>
-        <c:minorTickMark val="none"/>
-        <c:tickLblPos val="low"/>
-        <c:spPr>
-          <a:ln w="12700" cap="flat">
-            <a:solidFill>
-              <a:srgbClr val="888888"/>
-            </a:solidFill>
-            <a:prstDash val="solid"/>
-            <a:round/>
-          </a:ln>
-        </c:spPr>
-        <c:txPr>
-          <a:bodyPr/>
-          <a:lstStyle/>
-          <a:p>
-            <a:pPr>
-              <a:defRPr sz="900" b="0" i="0" u="none" strike="noStrike">
-                <a:solidFill>
-                  <a:srgbClr val="6B7A90"/>
-                </a:solidFill>
-                <a:latin typeface="Arial"/>
-              </a:defRPr>
-            </a:pPr>
-            <a:endParaRPr lang="en-US"/>
-          </a:p>
-        </c:txPr>
-        <c:crossAx val="2094734552"/>
-        <c:crosses val="autoZero"/>
-        <c:auto val="1"/>
-        <c:lblAlgn val="ctr"/>
-        <c:noMultiLvlLbl val="1"/>
-      </c:catAx>
-      <c:valAx>
-        <c:axId val="2094734552"/>
-        <c:scaling>
-          <c:orientation val="minMax"/>
-        </c:scaling>
-        <c:delete val="0"/>
-        <c:axPos val="l"/>
-        <c:majorGridlines>
-          <c:spPr>
-            <a:ln w="6350" cap="flat">
-              <a:solidFill>
-                <a:srgbClr val="E3ECF2"/>
-              </a:solidFill>
-              <a:prstDash val="solid"/>
-              <a:round/>
-            </a:ln>
-          </c:spPr>
-        </c:majorGridlines>
-        <c:numFmt formatCode="0.000" sourceLinked="0"/>
-        <c:majorTickMark val="out"/>
-        <c:minorTickMark val="none"/>
-        <c:tickLblPos val="nextTo"/>
-        <c:spPr>
-          <a:ln w="12700" cap="flat">
-            <a:solidFill>
-              <a:srgbClr val="888888"/>
-            </a:solidFill>
-            <a:prstDash val="solid"/>
-            <a:round/>
-          </a:ln>
-        </c:spPr>
-        <c:txPr>
-          <a:bodyPr/>
-          <a:lstStyle/>
-          <a:p>
-            <a:pPr>
-              <a:defRPr sz="800" b="0" i="0" u="none" strike="noStrike">
-                <a:solidFill>
-                  <a:srgbClr val="6B7A90"/>
-                </a:solidFill>
-                <a:latin typeface="Arial"/>
-              </a:defRPr>
-            </a:pPr>
-            <a:endParaRPr lang="en-US"/>
-          </a:p>
-        </c:txPr>
-        <c:crossAx val="2094734554"/>
-        <c:crosses val="autoZero"/>
-        <c:crossBetween val="between"/>
-      </c:valAx>
-      <c:spPr>
-        <a:noFill/>
-        <a:ln>
-          <a:noFill/>
-        </a:ln>
-        <a:effectLst/>
-      </c:spPr>
-    </c:plotArea>
-    <c:plotVisOnly val="1"/>
-    <c:dispBlanksAs val="span"/>
-  </c:chart>
-  <c:spPr>
-    <a:noFill/>
-    <a:ln>
-      <a:noFill/>
-    </a:ln>
-    <a:effectLst/>
-  </c:spPr>
-  <c:externalData r:id="rId1">
-    <c:autoUpdate val="0"/>
-  </c:externalData>
-</c:chartSpace>
-</file>
-
 <file path=ppt/notesMasters/notesMaster1.xml><?xml version="1.0" encoding="utf-8"?>
 <p:notesMaster xmlns:a="http://schemas.openxmlformats.org/drawingml/2006/main" xmlns:r="http://schemas.openxmlformats.org/officeDocument/2006/relationships" xmlns:p="http://schemas.openxmlformats.org/presentationml/2006/main">
   <p:cSld>
@@ -7159,8 +5746,8 @@
         </p:blipFill>
         <p:spPr>
           <a:xfrm>
-            <a:off x="640080" y="822960"/>
-            <a:ext cx="822960" cy="822960"/>
+            <a:off x="548640" y="731520"/>
+            <a:ext cx="731520" cy="731520"/>
           </a:xfrm>
           <a:prstGeom prst="rect">
             <a:avLst/>
@@ -7175,8 +5762,8 @@
         </p:nvSpPr>
         <p:spPr>
           <a:xfrm>
-            <a:off x="640080" y="1737360"/>
-            <a:ext cx="7863840" cy="914400"/>
+            <a:off x="548640" y="1554480"/>
+            <a:ext cx="4023360" cy="822960"/>
           </a:xfrm>
           <a:prstGeom prst="rect">
             <a:avLst/>
@@ -7192,7 +5779,7 @@
               <a:buNone/>
             </a:pPr>
             <a:r>
-              <a:rPr lang="en-US" sz="4600" b="1" dirty="0">
+              <a:rPr lang="en-US" sz="4200" b="1" dirty="0">
                 <a:solidFill>
                   <a:srgbClr val="FFFFFF"/>
                 </a:solidFill>
@@ -7202,7 +5789,7 @@
               </a:rPr>
               <a:t>因子挖掘</a:t>
             </a:r>
-            <a:endParaRPr lang="en-US" sz="4600" dirty="0"/>
+            <a:endParaRPr lang="en-US" sz="4200" dirty="0"/>
           </a:p>
         </p:txBody>
       </p:sp>
@@ -7214,8 +5801,8 @@
         </p:nvSpPr>
         <p:spPr>
           <a:xfrm>
-            <a:off x="640080" y="2651760"/>
-            <a:ext cx="7863840" cy="457200"/>
+            <a:off x="548640" y="2377440"/>
+            <a:ext cx="4023360" cy="731520"/>
           </a:xfrm>
           <a:prstGeom prst="rect">
             <a:avLst/>
@@ -7231,7 +5818,7 @@
               <a:buNone/>
             </a:pPr>
             <a:r>
-              <a:rPr lang="en-US" sz="2000" dirty="0">
+              <a:rPr lang="en-US" sz="1700" dirty="0">
                 <a:solidFill>
                   <a:srgbClr val="3BE0FF"/>
                 </a:solidFill>
@@ -7241,7 +5828,7 @@
               </a:rPr>
               <a:t>让机器找信号，让规则守底线 —— 15 分钟</a:t>
             </a:r>
-            <a:endParaRPr lang="en-US" sz="2000" dirty="0"/>
+            <a:endParaRPr lang="en-US" sz="1700" dirty="0"/>
           </a:p>
         </p:txBody>
       </p:sp>
@@ -7253,8 +5840,8 @@
         </p:nvSpPr>
         <p:spPr>
           <a:xfrm>
-            <a:off x="640080" y="3246120"/>
-            <a:ext cx="7680960" cy="548640"/>
+            <a:off x="548640" y="3200400"/>
+            <a:ext cx="3931920" cy="822960"/>
           </a:xfrm>
           <a:prstGeom prst="rect">
             <a:avLst/>
@@ -7270,7 +5857,7 @@
               <a:buNone/>
             </a:pPr>
             <a:r>
-              <a:rPr lang="en-US" sz="1250" dirty="0">
+              <a:rPr lang="en-US" sz="1150" dirty="0">
                 <a:solidFill>
                   <a:srgbClr val="AFC3DA"/>
                 </a:solidFill>
@@ -7280,13 +5867,110 @@
               </a:rPr>
               <a:t>以 AIQUANT TERMINAL 的「因子挖掘」板块为例：Loop Engineering 闭环挖掘 + 遗传进化，全程样本外验证</a:t>
             </a:r>
-            <a:endParaRPr lang="en-US" sz="1250" dirty="0"/>
+            <a:endParaRPr lang="en-US" sz="1150" dirty="0"/>
           </a:p>
         </p:txBody>
       </p:sp>
       <p:sp>
         <p:nvSpPr>
-          <p:cNvPr id="118" name="Text 115"/>
+          <p:cNvPr id="118" name="Shape 115"/>
+          <p:cNvSpPr/>
+          <p:nvPr/>
+        </p:nvSpPr>
+        <p:spPr>
+          <a:xfrm>
+            <a:off x="4700016" y="905256"/>
+            <a:ext cx="4133088" cy="2624328"/>
+          </a:xfrm>
+          <a:prstGeom prst="roundRect">
+            <a:avLst>
+              <a:gd name="adj" fmla="val 2787"/>
+            </a:avLst>
+          </a:prstGeom>
+          <a:solidFill>
+            <a:srgbClr val="13213A"/>
+          </a:solidFill>
+          <a:ln w="9525">
+            <a:solidFill>
+              <a:srgbClr val="2A3F5F"/>
+            </a:solidFill>
+            <a:prstDash val="solid"/>
+          </a:ln>
+          <a:effectLst>
+            <a:outerShdw sx="100000" sy="100000" kx="0" ky="0" algn="bl" rotWithShape="0" blurRad="76200" dist="25400" dir="5400000">
+              <a:srgbClr val="000000">
+                <a:alpha val="35000"/>
+              </a:srgbClr>
+            </a:outerShdw>
+          </a:effectLst>
+        </p:spPr>
+      </p:sp>
+      <p:pic>
+        <p:nvPicPr>
+          <p:cNvPr id="119" name="Image 1" descr="preencoded.png">    </p:cNvPr>
+          <p:cNvPicPr>
+            <a:picLocks noChangeAspect="1"/>
+          </p:cNvPicPr>
+          <p:nvPr/>
+        </p:nvPicPr>
+        <p:blipFill>
+          <a:blip r:embed="rId2"/>
+          <a:stretch>
+            <a:fillRect/>
+          </a:stretch>
+        </p:blipFill>
+        <p:spPr>
+          <a:xfrm>
+            <a:off x="4754880" y="960120"/>
+            <a:ext cx="4023360" cy="2514600"/>
+          </a:xfrm>
+          <a:prstGeom prst="rect">
+            <a:avLst/>
+          </a:prstGeom>
+        </p:spPr>
+      </p:pic>
+      <p:sp>
+        <p:nvSpPr>
+          <p:cNvPr id="120" name="Text 116"/>
+          <p:cNvSpPr txBox="1"/>
+          <p:nvPr/>
+        </p:nvSpPr>
+        <p:spPr>
+          <a:xfrm>
+            <a:off x="4754880" y="3538728"/>
+            <a:ext cx="4023360" cy="274320"/>
+          </a:xfrm>
+          <a:prstGeom prst="rect">
+            <a:avLst/>
+          </a:prstGeom>
+          <a:noFill/>
+          <a:ln/>
+        </p:spPr>
+        <p:txBody>
+          <a:bodyPr wrap="square" lIns="0" tIns="0" rIns="0" bIns="0" rtlCol="0" anchor="ctr"/>
+          <a:lstStyle/>
+          <a:p>
+            <a:pPr indent="0" marL="0">
+              <a:buNone/>
+            </a:pPr>
+            <a:r>
+              <a:rPr lang="en-US" sz="850" i="1" dirty="0">
+                <a:solidFill>
+                  <a:srgbClr val="6B7A90"/>
+                </a:solidFill>
+                <a:latin typeface="Microsoft YaHei" pitchFamily="34" charset="0"/>
+                <a:ea typeface="Microsoft YaHei" pitchFamily="34" charset="-122"/>
+                <a:cs typeface="Microsoft YaHei" pitchFamily="34" charset="-120"/>
+              </a:rPr>
+              <a:t>AIQUANT TERMINAL 主界面（真实截图）</a:t>
+            </a:r>
+            <a:endParaRPr lang="en-US" sz="850" dirty="0"/>
+          </a:p>
+        </p:txBody>
+      </p:sp>
+      <p:sp>
+        <p:nvSpPr>
+          <p:cNvPr id="121" name="Text 117"/>
           <p:cNvSpPr txBox="1"/>
           <p:nvPr/>
         </p:nvSpPr>
@@ -8218,53 +6902,35 @@
         </p:nvSpPr>
         <p:spPr>
           <a:xfrm>
-            <a:off x="4663440" y="1417320"/>
-            <a:ext cx="4023360" cy="1463040"/>
+            <a:off x="4608576" y="1362456"/>
+            <a:ext cx="4133088" cy="2356325"/>
           </a:xfrm>
           <a:prstGeom prst="roundRect">
             <a:avLst>
-              <a:gd name="adj" fmla="val 7500"/>
+              <a:gd name="adj" fmla="val 3104"/>
             </a:avLst>
           </a:prstGeom>
           <a:solidFill>
-            <a:srgbClr val="EEF6FA"/>
+            <a:srgbClr val="13213A"/>
           </a:solidFill>
           <a:ln w="9525">
             <a:solidFill>
-              <a:srgbClr val="D6E4EC"/>
-            </a:solidFill>
-            <a:prstDash val="solid"/>
-          </a:ln>
-        </p:spPr>
-      </p:sp>
-      <p:sp>
-        <p:nvSpPr>
-          <p:cNvPr id="30" name="Shape 28"/>
-          <p:cNvSpPr/>
-          <p:nvPr/>
-        </p:nvSpPr>
-        <p:spPr>
-          <a:xfrm>
-            <a:off x="4828032" y="1563624"/>
-            <a:ext cx="457200" cy="457200"/>
-          </a:xfrm>
-          <a:prstGeom prst="ellipse">
-            <a:avLst/>
-          </a:prstGeom>
-          <a:solidFill>
-            <a:srgbClr val="7C5CFF"/>
-          </a:solidFill>
-          <a:ln w="12700">
-            <a:solidFill>
-              <a:srgbClr val="7C5CFF"/>
-            </a:solidFill>
-            <a:prstDash val="solid"/>
-          </a:ln>
+              <a:srgbClr val="2A3F5F"/>
+            </a:solidFill>
+            <a:prstDash val="solid"/>
+          </a:ln>
+          <a:effectLst>
+            <a:outerShdw sx="100000" sy="100000" kx="0" ky="0" algn="bl" rotWithShape="0" blurRad="76200" dist="25400" dir="5400000">
+              <a:srgbClr val="000000">
+                <a:alpha val="35000"/>
+              </a:srgbClr>
+            </a:outerShdw>
+          </a:effectLst>
         </p:spPr>
       </p:sp>
       <p:pic>
         <p:nvPicPr>
-          <p:cNvPr id="31" name="Image 0" descr="preencoded.png">    </p:cNvPr>
+          <p:cNvPr id="30" name="Image 0" descr="preencoded.png">    </p:cNvPr>
           <p:cNvPicPr>
             <a:picLocks noChangeAspect="1"/>
           </p:cNvPicPr>
@@ -8278,8 +6944,8 @@
         </p:blipFill>
         <p:spPr>
           <a:xfrm>
-            <a:off x="4928616" y="1664208"/>
-            <a:ext cx="256032" cy="256032"/>
+            <a:off x="4663440" y="1417320"/>
+            <a:ext cx="4023360" cy="2246597"/>
           </a:xfrm>
           <a:prstGeom prst="rect">
             <a:avLst/>
@@ -8288,14 +6954,14 @@
       </p:pic>
       <p:sp>
         <p:nvSpPr>
-          <p:cNvPr id="32" name="Text 29"/>
+          <p:cNvPr id="31" name="Text 28"/>
           <p:cNvSpPr txBox="1"/>
           <p:nvPr/>
         </p:nvSpPr>
         <p:spPr>
           <a:xfrm>
-            <a:off x="5394960" y="1581912"/>
-            <a:ext cx="3108960" cy="384048"/>
+            <a:off x="4663440" y="3727925"/>
+            <a:ext cx="4023360" cy="274320"/>
           </a:xfrm>
           <a:prstGeom prst="rect">
             <a:avLst/>
@@ -8311,7 +6977,122 @@
               <a:buNone/>
             </a:pPr>
             <a:r>
-              <a:rPr lang="en-US" sz="1400" b="1" dirty="0">
+              <a:rPr lang="en-US" sz="850" i="1" dirty="0">
+                <a:solidFill>
+                  <a:srgbClr val="6B7A90"/>
+                </a:solidFill>
+                <a:latin typeface="Microsoft YaHei" pitchFamily="34" charset="0"/>
+                <a:ea typeface="Microsoft YaHei" pitchFamily="34" charset="-122"/>
+                <a:cs typeface="Microsoft YaHei" pitchFamily="34" charset="-120"/>
+              </a:rPr>
+              <a:t>进化实验室：冠军演化与名人堂实时刷新（真实截图）</a:t>
+            </a:r>
+            <a:endParaRPr lang="en-US" sz="850" dirty="0"/>
+          </a:p>
+        </p:txBody>
+      </p:sp>
+      <p:sp>
+        <p:nvSpPr>
+          <p:cNvPr id="32" name="Shape 29"/>
+          <p:cNvSpPr/>
+          <p:nvPr/>
+        </p:nvSpPr>
+        <p:spPr>
+          <a:xfrm>
+            <a:off x="4663440" y="3657600"/>
+            <a:ext cx="4023360" cy="1005840"/>
+          </a:xfrm>
+          <a:prstGeom prst="roundRect">
+            <a:avLst>
+              <a:gd name="adj" fmla="val 10909"/>
+            </a:avLst>
+          </a:prstGeom>
+          <a:solidFill>
+            <a:srgbClr val="EEF6FA"/>
+          </a:solidFill>
+          <a:ln w="9525">
+            <a:solidFill>
+              <a:srgbClr val="D6E4EC"/>
+            </a:solidFill>
+            <a:prstDash val="solid"/>
+          </a:ln>
+        </p:spPr>
+      </p:sp>
+      <p:sp>
+        <p:nvSpPr>
+          <p:cNvPr id="33" name="Shape 30"/>
+          <p:cNvSpPr/>
+          <p:nvPr/>
+        </p:nvSpPr>
+        <p:spPr>
+          <a:xfrm>
+            <a:off x="4773168" y="3749040"/>
+            <a:ext cx="329184" cy="329184"/>
+          </a:xfrm>
+          <a:prstGeom prst="ellipse">
+            <a:avLst/>
+          </a:prstGeom>
+          <a:solidFill>
+            <a:srgbClr val="7C5CFF"/>
+          </a:solidFill>
+          <a:ln w="12700">
+            <a:solidFill>
+              <a:srgbClr val="7C5CFF"/>
+            </a:solidFill>
+            <a:prstDash val="solid"/>
+          </a:ln>
+        </p:spPr>
+      </p:sp>
+      <p:pic>
+        <p:nvPicPr>
+          <p:cNvPr id="34" name="Image 1" descr="preencoded.png">    </p:cNvPr>
+          <p:cNvPicPr>
+            <a:picLocks noChangeAspect="1"/>
+          </p:cNvPicPr>
+          <p:nvPr/>
+        </p:nvPicPr>
+        <p:blipFill>
+          <a:blip r:embed="rId2"/>
+          <a:stretch>
+            <a:fillRect/>
+          </a:stretch>
+        </p:blipFill>
+        <p:spPr>
+          <a:xfrm>
+            <a:off x="4845588" y="3821460"/>
+            <a:ext cx="184343" cy="184343"/>
+          </a:xfrm>
+          <a:prstGeom prst="rect">
+            <a:avLst/>
+          </a:prstGeom>
+        </p:spPr>
+      </p:pic>
+      <p:sp>
+        <p:nvSpPr>
+          <p:cNvPr id="35" name="Text 31"/>
+          <p:cNvSpPr txBox="1"/>
+          <p:nvPr/>
+        </p:nvSpPr>
+        <p:spPr>
+          <a:xfrm>
+            <a:off x="5175504" y="3749040"/>
+            <a:ext cx="3419856" cy="329184"/>
+          </a:xfrm>
+          <a:prstGeom prst="rect">
+            <a:avLst/>
+          </a:prstGeom>
+          <a:noFill/>
+          <a:ln/>
+        </p:spPr>
+        <p:txBody>
+          <a:bodyPr wrap="square" lIns="0" tIns="0" rIns="0" bIns="0" rtlCol="0" anchor="ctr"/>
+          <a:lstStyle/>
+          <a:p>
+            <a:pPr indent="0" marL="0">
+              <a:buNone/>
+            </a:pPr>
+            <a:r>
+              <a:rPr lang="en-US" sz="1200" b="1" dirty="0">
                 <a:solidFill>
                   <a:srgbClr val="7C5CFF"/>
                 </a:solidFill>
@@ -8321,20 +7102,20 @@
               </a:rPr>
               <a:t>适应度里的三条修正</a:t>
             </a:r>
-            <a:endParaRPr lang="en-US" sz="1400" dirty="0"/>
+            <a:endParaRPr lang="en-US" sz="1200" dirty="0"/>
           </a:p>
         </p:txBody>
       </p:sp>
       <p:sp>
         <p:nvSpPr>
-          <p:cNvPr id="33" name="Text 30"/>
+          <p:cNvPr id="36" name="Text 32"/>
           <p:cNvSpPr txBox="1"/>
           <p:nvPr/>
         </p:nvSpPr>
         <p:spPr>
           <a:xfrm>
-            <a:off x="4846320" y="2057400"/>
-            <a:ext cx="3657600" cy="731520"/>
+            <a:off x="4800600" y="4114800"/>
+            <a:ext cx="3749040" cy="475488"/>
           </a:xfrm>
           <a:prstGeom prst="rect">
             <a:avLst/>
@@ -8350,7 +7131,7 @@
               <a:buNone/>
             </a:pPr>
             <a:r>
-              <a:rPr lang="en-US" sz="1100" dirty="0">
+              <a:rPr lang="en-US" sz="1000" dirty="0">
                 <a:solidFill>
                   <a:srgbClr val="13213A"/>
                 </a:solidFill>
@@ -8358,1062 +7139,12 @@
                 <a:ea typeface="Microsoft YaHei" pitchFamily="34" charset="-122"/>
                 <a:cs typeface="Microsoft YaHei" pitchFamily="34" charset="-120"/>
               </a:rPr>
-              <a:t>稳定的因子加分；每多一块积木扣一点分（防止越拼越长）；和已发现因子太像的直接打对折（逼着去别处找）。每代前 8 名进名人堂。</a:t>
+              <a:t>稳定加分 · 每多一块积木扣一点分 · 和已发现因子太像的打对折。每代前 8 名进名人堂。</a:t>
             </a:r>
-            <a:endParaRPr lang="en-US" sz="1100" dirty="0"/>
+            <a:endParaRPr lang="en-US" sz="1000" dirty="0"/>
           </a:p>
         </p:txBody>
       </p:sp>
-      <p:graphicFrame>
-        <p:nvGraphicFramePr>
-          <p:cNvPr id="11" name="Table 0"/>
-          <p:cNvGraphicFramePr>
-            <a:graphicFrameLocks noGrp="1"/>
-          </p:cNvGraphicFramePr>
-          <p:nvPr>
-            <p:extLst>
-              <p:ext uri="{D42A27DB-BD31-4B8C-83A1-F6EECF244321}">
-                <p14:modId xmlns:p14="http://schemas.microsoft.com/office/powerpoint/2010/main" val="1579011935"/>
-              </p:ext>
-            </p:extLst>
-          </p:nvPr>
-        </p:nvGraphicFramePr>
-        <p:xfrm>
-          <a:off x="4663440" y="3017520"/>
-          <a:ext cx="4023360" cy="914400"/>
-        </p:xfrm>
-        <a:graphic>
-          <a:graphicData uri="http://schemas.openxmlformats.org/drawingml/2006/table">
-            <a:tbl>
-              <a:tblPr/>
-              <a:tblGrid>
-                <a:gridCol w="1005840"/>
-                <a:gridCol w="1508760"/>
-                <a:gridCol w="1508760"/>
-              </a:tblGrid>
-              <a:tr h="310896">
-                <a:tc>
-                  <a:txBody>
-                    <a:bodyPr/>
-                    <a:lstStyle/>
-                    <a:p>
-                      <a:pPr indent="0" marL="0">
-                        <a:buNone/>
-                      </a:pPr>
-                      <a:endParaRPr lang="en-US" sz="950" dirty="0">
-                        <a:latin typeface="Microsoft YaHei" charset="0"/>
-                        <a:ea typeface="Microsoft YaHei" charset="0"/>
-                        <a:cs typeface="Microsoft YaHei" charset="0"/>
-                      </a:endParaRPr>
-                    </a:p>
-                  </a:txBody>
-                  <a:tcPr marL="91440" marR="91440" marT="45720" marB="45720" anchor="ctr">
-                    <a:lnL w="6350" cap="flat" cmpd="sng" algn="ctr">
-                      <a:solidFill>
-                        <a:srgbClr val="D6E4EC"/>
-                      </a:solidFill>
-                      <a:prstDash val="solid"/>
-                      <a:round/>
-                      <a:headEnd type="none" w="med" len="med"/>
-                      <a:tailEnd type="none" w="med" len="med"/>
-                    </a:lnL>
-                    <a:lnR w="6350" cap="flat" cmpd="sng" algn="ctr">
-                      <a:solidFill>
-                        <a:srgbClr val="D6E4EC"/>
-                      </a:solidFill>
-                      <a:prstDash val="solid"/>
-                      <a:round/>
-                      <a:headEnd type="none" w="med" len="med"/>
-                      <a:tailEnd type="none" w="med" len="med"/>
-                    </a:lnR>
-                    <a:lnT w="6350" cap="flat" cmpd="sng" algn="ctr">
-                      <a:solidFill>
-                        <a:srgbClr val="D6E4EC"/>
-                      </a:solidFill>
-                      <a:prstDash val="solid"/>
-                      <a:round/>
-                      <a:headEnd type="none" w="med" len="med"/>
-                      <a:tailEnd type="none" w="med" len="med"/>
-                    </a:lnT>
-                    <a:lnB w="6350" cap="flat" cmpd="sng" algn="ctr">
-                      <a:solidFill>
-                        <a:srgbClr val="D6E4EC"/>
-                      </a:solidFill>
-                      <a:prstDash val="solid"/>
-                      <a:round/>
-                      <a:headEnd type="none" w="med" len="med"/>
-                      <a:tailEnd type="none" w="med" len="med"/>
-                    </a:lnB>
-                    <a:solidFill>
-                      <a:srgbClr val="13213A"/>
-                    </a:solidFill>
-                  </a:tcPr>
-                </a:tc>
-                <a:tc>
-                  <a:txBody>
-                    <a:bodyPr/>
-                    <a:lstStyle/>
-                    <a:p>
-                      <a:pPr indent="0" marL="0">
-                        <a:buNone/>
-                      </a:pPr>
-                      <a:r>
-                        <a:rPr lang="en-US" sz="950" b="1" dirty="0">
-                          <a:solidFill>
-                            <a:srgbClr val="FFFFFF"/>
-                          </a:solidFill>
-                          <a:latin typeface="Microsoft YaHei" pitchFamily="34" charset="0"/>
-                          <a:ea typeface="Microsoft YaHei" pitchFamily="34" charset="-122"/>
-                          <a:cs typeface="Microsoft YaHei" pitchFamily="34" charset="-120"/>
-                        </a:rPr>
-                        <a:t>Loop Engineering</a:t>
-                      </a:r>
-                      <a:endParaRPr lang="en-US" sz="950" dirty="0">
-                        <a:latin typeface="Microsoft YaHei" charset="0"/>
-                        <a:ea typeface="Microsoft YaHei" charset="0"/>
-                        <a:cs typeface="Microsoft YaHei" charset="0"/>
-                      </a:endParaRPr>
-                    </a:p>
-                  </a:txBody>
-                  <a:tcPr marL="91440" marR="91440" marT="45720" marB="45720" anchor="ctr">
-                    <a:lnL w="6350" cap="flat" cmpd="sng" algn="ctr">
-                      <a:solidFill>
-                        <a:srgbClr val="D6E4EC"/>
-                      </a:solidFill>
-                      <a:prstDash val="solid"/>
-                      <a:round/>
-                      <a:headEnd type="none" w="med" len="med"/>
-                      <a:tailEnd type="none" w="med" len="med"/>
-                    </a:lnL>
-                    <a:lnR w="6350" cap="flat" cmpd="sng" algn="ctr">
-                      <a:solidFill>
-                        <a:srgbClr val="D6E4EC"/>
-                      </a:solidFill>
-                      <a:prstDash val="solid"/>
-                      <a:round/>
-                      <a:headEnd type="none" w="med" len="med"/>
-                      <a:tailEnd type="none" w="med" len="med"/>
-                    </a:lnR>
-                    <a:lnT w="6350" cap="flat" cmpd="sng" algn="ctr">
-                      <a:solidFill>
-                        <a:srgbClr val="D6E4EC"/>
-                      </a:solidFill>
-                      <a:prstDash val="solid"/>
-                      <a:round/>
-                      <a:headEnd type="none" w="med" len="med"/>
-                      <a:tailEnd type="none" w="med" len="med"/>
-                    </a:lnT>
-                    <a:lnB w="6350" cap="flat" cmpd="sng" algn="ctr">
-                      <a:solidFill>
-                        <a:srgbClr val="D6E4EC"/>
-                      </a:solidFill>
-                      <a:prstDash val="solid"/>
-                      <a:round/>
-                      <a:headEnd type="none" w="med" len="med"/>
-                      <a:tailEnd type="none" w="med" len="med"/>
-                    </a:lnB>
-                    <a:solidFill>
-                      <a:srgbClr val="13213A"/>
-                    </a:solidFill>
-                  </a:tcPr>
-                </a:tc>
-                <a:tc>
-                  <a:txBody>
-                    <a:bodyPr/>
-                    <a:lstStyle/>
-                    <a:p>
-                      <a:pPr indent="0" marL="0">
-                        <a:buNone/>
-                      </a:pPr>
-                      <a:r>
-                        <a:rPr lang="en-US" sz="950" b="1" dirty="0">
-                          <a:solidFill>
-                            <a:srgbClr val="FFFFFF"/>
-                          </a:solidFill>
-                          <a:latin typeface="Microsoft YaHei" pitchFamily="34" charset="0"/>
-                          <a:ea typeface="Microsoft YaHei" pitchFamily="34" charset="-122"/>
-                          <a:cs typeface="Microsoft YaHei" pitchFamily="34" charset="-120"/>
-                        </a:rPr>
-                        <a:t>遗传编程</a:t>
-                      </a:r>
-                      <a:endParaRPr lang="en-US" sz="950" dirty="0">
-                        <a:latin typeface="Microsoft YaHei" charset="0"/>
-                        <a:ea typeface="Microsoft YaHei" charset="0"/>
-                        <a:cs typeface="Microsoft YaHei" charset="0"/>
-                      </a:endParaRPr>
-                    </a:p>
-                  </a:txBody>
-                  <a:tcPr marL="91440" marR="91440" marT="45720" marB="45720" anchor="ctr">
-                    <a:lnL w="6350" cap="flat" cmpd="sng" algn="ctr">
-                      <a:solidFill>
-                        <a:srgbClr val="D6E4EC"/>
-                      </a:solidFill>
-                      <a:prstDash val="solid"/>
-                      <a:round/>
-                      <a:headEnd type="none" w="med" len="med"/>
-                      <a:tailEnd type="none" w="med" len="med"/>
-                    </a:lnL>
-                    <a:lnR w="6350" cap="flat" cmpd="sng" algn="ctr">
-                      <a:solidFill>
-                        <a:srgbClr val="D6E4EC"/>
-                      </a:solidFill>
-                      <a:prstDash val="solid"/>
-                      <a:round/>
-                      <a:headEnd type="none" w="med" len="med"/>
-                      <a:tailEnd type="none" w="med" len="med"/>
-                    </a:lnR>
-                    <a:lnT w="6350" cap="flat" cmpd="sng" algn="ctr">
-                      <a:solidFill>
-                        <a:srgbClr val="D6E4EC"/>
-                      </a:solidFill>
-                      <a:prstDash val="solid"/>
-                      <a:round/>
-                      <a:headEnd type="none" w="med" len="med"/>
-                      <a:tailEnd type="none" w="med" len="med"/>
-                    </a:lnT>
-                    <a:lnB w="6350" cap="flat" cmpd="sng" algn="ctr">
-                      <a:solidFill>
-                        <a:srgbClr val="D6E4EC"/>
-                      </a:solidFill>
-                      <a:prstDash val="solid"/>
-                      <a:round/>
-                      <a:headEnd type="none" w="med" len="med"/>
-                      <a:tailEnd type="none" w="med" len="med"/>
-                    </a:lnB>
-                    <a:solidFill>
-                      <a:srgbClr val="13213A"/>
-                    </a:solidFill>
-                  </a:tcPr>
-                </a:tc>
-              </a:tr>
-              <a:tr h="310896">
-                <a:tc>
-                  <a:txBody>
-                    <a:bodyPr/>
-                    <a:lstStyle/>
-                    <a:p>
-                      <a:pPr indent="0" marL="0">
-                        <a:buNone/>
-                      </a:pPr>
-                      <a:r>
-                        <a:rPr lang="en-US" sz="850" dirty="0">
-                          <a:solidFill>
-                            <a:srgbClr val="13213A"/>
-                          </a:solidFill>
-                          <a:latin typeface="Microsoft YaHei" pitchFamily="34" charset="0"/>
-                          <a:ea typeface="Microsoft YaHei" pitchFamily="34" charset="-122"/>
-                          <a:cs typeface="Microsoft YaHei" pitchFamily="34" charset="-120"/>
-                        </a:rPr>
-                        <a:t>候选从哪来</a:t>
-                      </a:r>
-                      <a:endParaRPr lang="en-US" sz="850" dirty="0">
-                        <a:latin typeface="Microsoft YaHei" charset="0"/>
-                        <a:ea typeface="Microsoft YaHei" charset="0"/>
-                        <a:cs typeface="Microsoft YaHei" charset="0"/>
-                      </a:endParaRPr>
-                    </a:p>
-                  </a:txBody>
-                  <a:tcPr marL="91440" marR="91440" marT="45720" marB="45720" anchor="ctr">
-                    <a:lnL w="6350" cap="flat" cmpd="sng" algn="ctr">
-                      <a:solidFill>
-                        <a:srgbClr val="D6E4EC"/>
-                      </a:solidFill>
-                      <a:prstDash val="solid"/>
-                      <a:round/>
-                      <a:headEnd type="none" w="med" len="med"/>
-                      <a:tailEnd type="none" w="med" len="med"/>
-                    </a:lnL>
-                    <a:lnR w="6350" cap="flat" cmpd="sng" algn="ctr">
-                      <a:solidFill>
-                        <a:srgbClr val="D6E4EC"/>
-                      </a:solidFill>
-                      <a:prstDash val="solid"/>
-                      <a:round/>
-                      <a:headEnd type="none" w="med" len="med"/>
-                      <a:tailEnd type="none" w="med" len="med"/>
-                    </a:lnR>
-                    <a:lnT w="6350" cap="flat" cmpd="sng" algn="ctr">
-                      <a:solidFill>
-                        <a:srgbClr val="D6E4EC"/>
-                      </a:solidFill>
-                      <a:prstDash val="solid"/>
-                      <a:round/>
-                      <a:headEnd type="none" w="med" len="med"/>
-                      <a:tailEnd type="none" w="med" len="med"/>
-                    </a:lnT>
-                    <a:lnB w="6350" cap="flat" cmpd="sng" algn="ctr">
-                      <a:solidFill>
-                        <a:srgbClr val="D6E4EC"/>
-                      </a:solidFill>
-                      <a:prstDash val="solid"/>
-                      <a:round/>
-                      <a:headEnd type="none" w="med" len="med"/>
-                      <a:tailEnd type="none" w="med" len="med"/>
-                    </a:lnB>
-                    <a:solidFill>
-                      <a:srgbClr val="FFFFFF"/>
-                    </a:solidFill>
-                  </a:tcPr>
-                </a:tc>
-                <a:tc>
-                  <a:txBody>
-                    <a:bodyPr/>
-                    <a:lstStyle/>
-                    <a:p>
-                      <a:pPr indent="0" marL="0">
-                        <a:buNone/>
-                      </a:pPr>
-                      <a:r>
-                        <a:rPr lang="en-US" sz="850" dirty="0">
-                          <a:solidFill>
-                            <a:srgbClr val="13213A"/>
-                          </a:solidFill>
-                          <a:latin typeface="Microsoft YaHei" pitchFamily="34" charset="0"/>
-                          <a:ea typeface="Microsoft YaHei" pitchFamily="34" charset="-122"/>
-                          <a:cs typeface="Microsoft YaHei" pitchFamily="34" charset="-120"/>
-                        </a:rPr>
-                        <a:t>AI，自带金融常识</a:t>
-                      </a:r>
-                      <a:endParaRPr lang="en-US" sz="850" dirty="0">
-                        <a:latin typeface="Microsoft YaHei" charset="0"/>
-                        <a:ea typeface="Microsoft YaHei" charset="0"/>
-                        <a:cs typeface="Microsoft YaHei" charset="0"/>
-                      </a:endParaRPr>
-                    </a:p>
-                  </a:txBody>
-                  <a:tcPr marL="91440" marR="91440" marT="45720" marB="45720" anchor="ctr">
-                    <a:lnL w="6350" cap="flat" cmpd="sng" algn="ctr">
-                      <a:solidFill>
-                        <a:srgbClr val="D6E4EC"/>
-                      </a:solidFill>
-                      <a:prstDash val="solid"/>
-                      <a:round/>
-                      <a:headEnd type="none" w="med" len="med"/>
-                      <a:tailEnd type="none" w="med" len="med"/>
-                    </a:lnL>
-                    <a:lnR w="6350" cap="flat" cmpd="sng" algn="ctr">
-                      <a:solidFill>
-                        <a:srgbClr val="D6E4EC"/>
-                      </a:solidFill>
-                      <a:prstDash val="solid"/>
-                      <a:round/>
-                      <a:headEnd type="none" w="med" len="med"/>
-                      <a:tailEnd type="none" w="med" len="med"/>
-                    </a:lnR>
-                    <a:lnT w="6350" cap="flat" cmpd="sng" algn="ctr">
-                      <a:solidFill>
-                        <a:srgbClr val="D6E4EC"/>
-                      </a:solidFill>
-                      <a:prstDash val="solid"/>
-                      <a:round/>
-                      <a:headEnd type="none" w="med" len="med"/>
-                      <a:tailEnd type="none" w="med" len="med"/>
-                    </a:lnT>
-                    <a:lnB w="6350" cap="flat" cmpd="sng" algn="ctr">
-                      <a:solidFill>
-                        <a:srgbClr val="D6E4EC"/>
-                      </a:solidFill>
-                      <a:prstDash val="solid"/>
-                      <a:round/>
-                      <a:headEnd type="none" w="med" len="med"/>
-                      <a:tailEnd type="none" w="med" len="med"/>
-                    </a:lnB>
-                    <a:solidFill>
-                      <a:srgbClr val="FFFFFF"/>
-                    </a:solidFill>
-                  </a:tcPr>
-                </a:tc>
-                <a:tc>
-                  <a:txBody>
-                    <a:bodyPr/>
-                    <a:lstStyle/>
-                    <a:p>
-                      <a:pPr indent="0" marL="0">
-                        <a:buNone/>
-                      </a:pPr>
-                      <a:r>
-                        <a:rPr lang="en-US" sz="850" dirty="0">
-                          <a:solidFill>
-                            <a:srgbClr val="13213A"/>
-                          </a:solidFill>
-                          <a:latin typeface="Microsoft YaHei" pitchFamily="34" charset="0"/>
-                          <a:ea typeface="Microsoft YaHei" pitchFamily="34" charset="-122"/>
-                          <a:cs typeface="Microsoft YaHei" pitchFamily="34" charset="-120"/>
-                        </a:rPr>
-                        <a:t>随机组合、变异</a:t>
-                      </a:r>
-                      <a:endParaRPr lang="en-US" sz="850" dirty="0">
-                        <a:latin typeface="Microsoft YaHei" charset="0"/>
-                        <a:ea typeface="Microsoft YaHei" charset="0"/>
-                        <a:cs typeface="Microsoft YaHei" charset="0"/>
-                      </a:endParaRPr>
-                    </a:p>
-                  </a:txBody>
-                  <a:tcPr marL="91440" marR="91440" marT="45720" marB="45720" anchor="ctr">
-                    <a:lnL w="6350" cap="flat" cmpd="sng" algn="ctr">
-                      <a:solidFill>
-                        <a:srgbClr val="D6E4EC"/>
-                      </a:solidFill>
-                      <a:prstDash val="solid"/>
-                      <a:round/>
-                      <a:headEnd type="none" w="med" len="med"/>
-                      <a:tailEnd type="none" w="med" len="med"/>
-                    </a:lnL>
-                    <a:lnR w="6350" cap="flat" cmpd="sng" algn="ctr">
-                      <a:solidFill>
-                        <a:srgbClr val="D6E4EC"/>
-                      </a:solidFill>
-                      <a:prstDash val="solid"/>
-                      <a:round/>
-                      <a:headEnd type="none" w="med" len="med"/>
-                      <a:tailEnd type="none" w="med" len="med"/>
-                    </a:lnR>
-                    <a:lnT w="6350" cap="flat" cmpd="sng" algn="ctr">
-                      <a:solidFill>
-                        <a:srgbClr val="D6E4EC"/>
-                      </a:solidFill>
-                      <a:prstDash val="solid"/>
-                      <a:round/>
-                      <a:headEnd type="none" w="med" len="med"/>
-                      <a:tailEnd type="none" w="med" len="med"/>
-                    </a:lnT>
-                    <a:lnB w="6350" cap="flat" cmpd="sng" algn="ctr">
-                      <a:solidFill>
-                        <a:srgbClr val="D6E4EC"/>
-                      </a:solidFill>
-                      <a:prstDash val="solid"/>
-                      <a:round/>
-                      <a:headEnd type="none" w="med" len="med"/>
-                      <a:tailEnd type="none" w="med" len="med"/>
-                    </a:lnB>
-                    <a:solidFill>
-                      <a:srgbClr val="FFFFFF"/>
-                    </a:solidFill>
-                  </a:tcPr>
-                </a:tc>
-              </a:tr>
-              <a:tr h="310896">
-                <a:tc>
-                  <a:txBody>
-                    <a:bodyPr/>
-                    <a:lstStyle/>
-                    <a:p>
-                      <a:pPr indent="0" marL="0">
-                        <a:buNone/>
-                      </a:pPr>
-                      <a:r>
-                        <a:rPr lang="en-US" sz="850" dirty="0">
-                          <a:solidFill>
-                            <a:srgbClr val="13213A"/>
-                          </a:solidFill>
-                          <a:latin typeface="Microsoft YaHei" pitchFamily="34" charset="0"/>
-                          <a:ea typeface="Microsoft YaHei" pitchFamily="34" charset="-122"/>
-                          <a:cs typeface="Microsoft YaHei" pitchFamily="34" charset="-120"/>
-                        </a:rPr>
-                        <a:t>怎么用反馈</a:t>
-                      </a:r>
-                      <a:endParaRPr lang="en-US" sz="850" dirty="0">
-                        <a:latin typeface="Microsoft YaHei" charset="0"/>
-                        <a:ea typeface="Microsoft YaHei" charset="0"/>
-                        <a:cs typeface="Microsoft YaHei" charset="0"/>
-                      </a:endParaRPr>
-                    </a:p>
-                  </a:txBody>
-                  <a:tcPr marL="91440" marR="91440" marT="45720" marB="45720" anchor="ctr">
-                    <a:lnL w="6350" cap="flat" cmpd="sng" algn="ctr">
-                      <a:solidFill>
-                        <a:srgbClr val="D6E4EC"/>
-                      </a:solidFill>
-                      <a:prstDash val="solid"/>
-                      <a:round/>
-                      <a:headEnd type="none" w="med" len="med"/>
-                      <a:tailEnd type="none" w="med" len="med"/>
-                    </a:lnL>
-                    <a:lnR w="6350" cap="flat" cmpd="sng" algn="ctr">
-                      <a:solidFill>
-                        <a:srgbClr val="D6E4EC"/>
-                      </a:solidFill>
-                      <a:prstDash val="solid"/>
-                      <a:round/>
-                      <a:headEnd type="none" w="med" len="med"/>
-                      <a:tailEnd type="none" w="med" len="med"/>
-                    </a:lnR>
-                    <a:lnT w="6350" cap="flat" cmpd="sng" algn="ctr">
-                      <a:solidFill>
-                        <a:srgbClr val="D6E4EC"/>
-                      </a:solidFill>
-                      <a:prstDash val="solid"/>
-                      <a:round/>
-                      <a:headEnd type="none" w="med" len="med"/>
-                      <a:tailEnd type="none" w="med" len="med"/>
-                    </a:lnT>
-                    <a:lnB w="6350" cap="flat" cmpd="sng" algn="ctr">
-                      <a:solidFill>
-                        <a:srgbClr val="D6E4EC"/>
-                      </a:solidFill>
-                      <a:prstDash val="solid"/>
-                      <a:round/>
-                      <a:headEnd type="none" w="med" len="med"/>
-                      <a:tailEnd type="none" w="med" len="med"/>
-                    </a:lnB>
-                    <a:solidFill>
-                      <a:srgbClr val="FFFFFF"/>
-                    </a:solidFill>
-                  </a:tcPr>
-                </a:tc>
-                <a:tc>
-                  <a:txBody>
-                    <a:bodyPr/>
-                    <a:lstStyle/>
-                    <a:p>
-                      <a:pPr indent="0" marL="0">
-                        <a:buNone/>
-                      </a:pPr>
-                      <a:r>
-                        <a:rPr lang="en-US" sz="850" dirty="0">
-                          <a:solidFill>
-                            <a:srgbClr val="13213A"/>
-                          </a:solidFill>
-                          <a:latin typeface="Microsoft YaHei" pitchFamily="34" charset="0"/>
-                          <a:ea typeface="Microsoft YaHei" pitchFamily="34" charset="-122"/>
-                          <a:cs typeface="Microsoft YaHei" pitchFamily="34" charset="-120"/>
-                        </a:rPr>
-                        <a:t>理由写成文字放回题目</a:t>
-                      </a:r>
-                      <a:endParaRPr lang="en-US" sz="850" dirty="0">
-                        <a:latin typeface="Microsoft YaHei" charset="0"/>
-                        <a:ea typeface="Microsoft YaHei" charset="0"/>
-                        <a:cs typeface="Microsoft YaHei" charset="0"/>
-                      </a:endParaRPr>
-                    </a:p>
-                  </a:txBody>
-                  <a:tcPr marL="91440" marR="91440" marT="45720" marB="45720" anchor="ctr">
-                    <a:lnL w="6350" cap="flat" cmpd="sng" algn="ctr">
-                      <a:solidFill>
-                        <a:srgbClr val="D6E4EC"/>
-                      </a:solidFill>
-                      <a:prstDash val="solid"/>
-                      <a:round/>
-                      <a:headEnd type="none" w="med" len="med"/>
-                      <a:tailEnd type="none" w="med" len="med"/>
-                    </a:lnL>
-                    <a:lnR w="6350" cap="flat" cmpd="sng" algn="ctr">
-                      <a:solidFill>
-                        <a:srgbClr val="D6E4EC"/>
-                      </a:solidFill>
-                      <a:prstDash val="solid"/>
-                      <a:round/>
-                      <a:headEnd type="none" w="med" len="med"/>
-                      <a:tailEnd type="none" w="med" len="med"/>
-                    </a:lnR>
-                    <a:lnT w="6350" cap="flat" cmpd="sng" algn="ctr">
-                      <a:solidFill>
-                        <a:srgbClr val="D6E4EC"/>
-                      </a:solidFill>
-                      <a:prstDash val="solid"/>
-                      <a:round/>
-                      <a:headEnd type="none" w="med" len="med"/>
-                      <a:tailEnd type="none" w="med" len="med"/>
-                    </a:lnT>
-                    <a:lnB w="6350" cap="flat" cmpd="sng" algn="ctr">
-                      <a:solidFill>
-                        <a:srgbClr val="D6E4EC"/>
-                      </a:solidFill>
-                      <a:prstDash val="solid"/>
-                      <a:round/>
-                      <a:headEnd type="none" w="med" len="med"/>
-                      <a:tailEnd type="none" w="med" len="med"/>
-                    </a:lnB>
-                    <a:solidFill>
-                      <a:srgbClr val="FFFFFF"/>
-                    </a:solidFill>
-                  </a:tcPr>
-                </a:tc>
-                <a:tc>
-                  <a:txBody>
-                    <a:bodyPr/>
-                    <a:lstStyle/>
-                    <a:p>
-                      <a:pPr indent="0" marL="0">
-                        <a:buNone/>
-                      </a:pPr>
-                      <a:r>
-                        <a:rPr lang="en-US" sz="850" dirty="0">
-                          <a:solidFill>
-                            <a:srgbClr val="13213A"/>
-                          </a:solidFill>
-                          <a:latin typeface="Microsoft YaHei" pitchFamily="34" charset="0"/>
-                          <a:ea typeface="Microsoft YaHei" pitchFamily="34" charset="-122"/>
-                          <a:cs typeface="Microsoft YaHei" pitchFamily="34" charset="-120"/>
-                        </a:rPr>
-                        <a:t>只看一个适应度数字</a:t>
-                      </a:r>
-                      <a:endParaRPr lang="en-US" sz="850" dirty="0">
-                        <a:latin typeface="Microsoft YaHei" charset="0"/>
-                        <a:ea typeface="Microsoft YaHei" charset="0"/>
-                        <a:cs typeface="Microsoft YaHei" charset="0"/>
-                      </a:endParaRPr>
-                    </a:p>
-                  </a:txBody>
-                  <a:tcPr marL="91440" marR="91440" marT="45720" marB="45720" anchor="ctr">
-                    <a:lnL w="6350" cap="flat" cmpd="sng" algn="ctr">
-                      <a:solidFill>
-                        <a:srgbClr val="D6E4EC"/>
-                      </a:solidFill>
-                      <a:prstDash val="solid"/>
-                      <a:round/>
-                      <a:headEnd type="none" w="med" len="med"/>
-                      <a:tailEnd type="none" w="med" len="med"/>
-                    </a:lnL>
-                    <a:lnR w="6350" cap="flat" cmpd="sng" algn="ctr">
-                      <a:solidFill>
-                        <a:srgbClr val="D6E4EC"/>
-                      </a:solidFill>
-                      <a:prstDash val="solid"/>
-                      <a:round/>
-                      <a:headEnd type="none" w="med" len="med"/>
-                      <a:tailEnd type="none" w="med" len="med"/>
-                    </a:lnR>
-                    <a:lnT w="6350" cap="flat" cmpd="sng" algn="ctr">
-                      <a:solidFill>
-                        <a:srgbClr val="D6E4EC"/>
-                      </a:solidFill>
-                      <a:prstDash val="solid"/>
-                      <a:round/>
-                      <a:headEnd type="none" w="med" len="med"/>
-                      <a:tailEnd type="none" w="med" len="med"/>
-                    </a:lnT>
-                    <a:lnB w="6350" cap="flat" cmpd="sng" algn="ctr">
-                      <a:solidFill>
-                        <a:srgbClr val="D6E4EC"/>
-                      </a:solidFill>
-                      <a:prstDash val="solid"/>
-                      <a:round/>
-                      <a:headEnd type="none" w="med" len="med"/>
-                      <a:tailEnd type="none" w="med" len="med"/>
-                    </a:lnB>
-                    <a:solidFill>
-                      <a:srgbClr val="FFFFFF"/>
-                    </a:solidFill>
-                  </a:tcPr>
-                </a:tc>
-              </a:tr>
-              <a:tr h="310896">
-                <a:tc>
-                  <a:txBody>
-                    <a:bodyPr/>
-                    <a:lstStyle/>
-                    <a:p>
-                      <a:pPr indent="0" marL="0">
-                        <a:buNone/>
-                      </a:pPr>
-                      <a:r>
-                        <a:rPr lang="en-US" sz="850" dirty="0">
-                          <a:solidFill>
-                            <a:srgbClr val="13213A"/>
-                          </a:solidFill>
-                          <a:latin typeface="Microsoft YaHei" pitchFamily="34" charset="0"/>
-                          <a:ea typeface="Microsoft YaHei" pitchFamily="34" charset="-122"/>
-                          <a:cs typeface="Microsoft YaHei" pitchFamily="34" charset="-120"/>
-                        </a:rPr>
-                        <a:t>长处</a:t>
-                      </a:r>
-                      <a:endParaRPr lang="en-US" sz="850" dirty="0">
-                        <a:latin typeface="Microsoft YaHei" charset="0"/>
-                        <a:ea typeface="Microsoft YaHei" charset="0"/>
-                        <a:cs typeface="Microsoft YaHei" charset="0"/>
-                      </a:endParaRPr>
-                    </a:p>
-                  </a:txBody>
-                  <a:tcPr marL="91440" marR="91440" marT="45720" marB="45720" anchor="ctr">
-                    <a:lnL w="6350" cap="flat" cmpd="sng" algn="ctr">
-                      <a:solidFill>
-                        <a:srgbClr val="D6E4EC"/>
-                      </a:solidFill>
-                      <a:prstDash val="solid"/>
-                      <a:round/>
-                      <a:headEnd type="none" w="med" len="med"/>
-                      <a:tailEnd type="none" w="med" len="med"/>
-                    </a:lnL>
-                    <a:lnR w="6350" cap="flat" cmpd="sng" algn="ctr">
-                      <a:solidFill>
-                        <a:srgbClr val="D6E4EC"/>
-                      </a:solidFill>
-                      <a:prstDash val="solid"/>
-                      <a:round/>
-                      <a:headEnd type="none" w="med" len="med"/>
-                      <a:tailEnd type="none" w="med" len="med"/>
-                    </a:lnR>
-                    <a:lnT w="6350" cap="flat" cmpd="sng" algn="ctr">
-                      <a:solidFill>
-                        <a:srgbClr val="D6E4EC"/>
-                      </a:solidFill>
-                      <a:prstDash val="solid"/>
-                      <a:round/>
-                      <a:headEnd type="none" w="med" len="med"/>
-                      <a:tailEnd type="none" w="med" len="med"/>
-                    </a:lnT>
-                    <a:lnB w="6350" cap="flat" cmpd="sng" algn="ctr">
-                      <a:solidFill>
-                        <a:srgbClr val="D6E4EC"/>
-                      </a:solidFill>
-                      <a:prstDash val="solid"/>
-                      <a:round/>
-                      <a:headEnd type="none" w="med" len="med"/>
-                      <a:tailEnd type="none" w="med" len="med"/>
-                    </a:lnB>
-                    <a:solidFill>
-                      <a:srgbClr val="FFFFFF"/>
-                    </a:solidFill>
-                  </a:tcPr>
-                </a:tc>
-                <a:tc>
-                  <a:txBody>
-                    <a:bodyPr/>
-                    <a:lstStyle/>
-                    <a:p>
-                      <a:pPr indent="0" marL="0">
-                        <a:buNone/>
-                      </a:pPr>
-                      <a:r>
-                        <a:rPr lang="en-US" sz="850" dirty="0">
-                          <a:solidFill>
-                            <a:srgbClr val="13213A"/>
-                          </a:solidFill>
-                          <a:latin typeface="Microsoft YaHei" pitchFamily="34" charset="0"/>
-                          <a:ea typeface="Microsoft YaHei" pitchFamily="34" charset="-122"/>
-                          <a:cs typeface="Microsoft YaHei" pitchFamily="34" charset="-120"/>
-                        </a:rPr>
-                        <a:t>能解释、能听懂换方向</a:t>
-                      </a:r>
-                      <a:endParaRPr lang="en-US" sz="850" dirty="0">
-                        <a:latin typeface="Microsoft YaHei" charset="0"/>
-                        <a:ea typeface="Microsoft YaHei" charset="0"/>
-                        <a:cs typeface="Microsoft YaHei" charset="0"/>
-                      </a:endParaRPr>
-                    </a:p>
-                  </a:txBody>
-                  <a:tcPr marL="91440" marR="91440" marT="45720" marB="45720" anchor="ctr">
-                    <a:lnL w="6350" cap="flat" cmpd="sng" algn="ctr">
-                      <a:solidFill>
-                        <a:srgbClr val="D6E4EC"/>
-                      </a:solidFill>
-                      <a:prstDash val="solid"/>
-                      <a:round/>
-                      <a:headEnd type="none" w="med" len="med"/>
-                      <a:tailEnd type="none" w="med" len="med"/>
-                    </a:lnL>
-                    <a:lnR w="6350" cap="flat" cmpd="sng" algn="ctr">
-                      <a:solidFill>
-                        <a:srgbClr val="D6E4EC"/>
-                      </a:solidFill>
-                      <a:prstDash val="solid"/>
-                      <a:round/>
-                      <a:headEnd type="none" w="med" len="med"/>
-                      <a:tailEnd type="none" w="med" len="med"/>
-                    </a:lnR>
-                    <a:lnT w="6350" cap="flat" cmpd="sng" algn="ctr">
-                      <a:solidFill>
-                        <a:srgbClr val="D6E4EC"/>
-                      </a:solidFill>
-                      <a:prstDash val="solid"/>
-                      <a:round/>
-                      <a:headEnd type="none" w="med" len="med"/>
-                      <a:tailEnd type="none" w="med" len="med"/>
-                    </a:lnT>
-                    <a:lnB w="6350" cap="flat" cmpd="sng" algn="ctr">
-                      <a:solidFill>
-                        <a:srgbClr val="D6E4EC"/>
-                      </a:solidFill>
-                      <a:prstDash val="solid"/>
-                      <a:round/>
-                      <a:headEnd type="none" w="med" len="med"/>
-                      <a:tailEnd type="none" w="med" len="med"/>
-                    </a:lnB>
-                    <a:solidFill>
-                      <a:srgbClr val="FFFFFF"/>
-                    </a:solidFill>
-                  </a:tcPr>
-                </a:tc>
-                <a:tc>
-                  <a:txBody>
-                    <a:bodyPr/>
-                    <a:lstStyle/>
-                    <a:p>
-                      <a:pPr indent="0" marL="0">
-                        <a:buNone/>
-                      </a:pPr>
-                      <a:r>
-                        <a:rPr lang="en-US" sz="850" dirty="0">
-                          <a:solidFill>
-                            <a:srgbClr val="13213A"/>
-                          </a:solidFill>
-                          <a:latin typeface="Microsoft YaHei" pitchFamily="34" charset="0"/>
-                          <a:ea typeface="Microsoft YaHei" pitchFamily="34" charset="-122"/>
-                          <a:cs typeface="Microsoft YaHei" pitchFamily="34" charset="-120"/>
-                        </a:rPr>
-                        <a:t>便宜、可并行、不受 AI 知识局限</a:t>
-                      </a:r>
-                      <a:endParaRPr lang="en-US" sz="850" dirty="0">
-                        <a:latin typeface="Microsoft YaHei" charset="0"/>
-                        <a:ea typeface="Microsoft YaHei" charset="0"/>
-                        <a:cs typeface="Microsoft YaHei" charset="0"/>
-                      </a:endParaRPr>
-                    </a:p>
-                  </a:txBody>
-                  <a:tcPr marL="91440" marR="91440" marT="45720" marB="45720" anchor="ctr">
-                    <a:lnL w="6350" cap="flat" cmpd="sng" algn="ctr">
-                      <a:solidFill>
-                        <a:srgbClr val="D6E4EC"/>
-                      </a:solidFill>
-                      <a:prstDash val="solid"/>
-                      <a:round/>
-                      <a:headEnd type="none" w="med" len="med"/>
-                      <a:tailEnd type="none" w="med" len="med"/>
-                    </a:lnL>
-                    <a:lnR w="6350" cap="flat" cmpd="sng" algn="ctr">
-                      <a:solidFill>
-                        <a:srgbClr val="D6E4EC"/>
-                      </a:solidFill>
-                      <a:prstDash val="solid"/>
-                      <a:round/>
-                      <a:headEnd type="none" w="med" len="med"/>
-                      <a:tailEnd type="none" w="med" len="med"/>
-                    </a:lnR>
-                    <a:lnT w="6350" cap="flat" cmpd="sng" algn="ctr">
-                      <a:solidFill>
-                        <a:srgbClr val="D6E4EC"/>
-                      </a:solidFill>
-                      <a:prstDash val="solid"/>
-                      <a:round/>
-                      <a:headEnd type="none" w="med" len="med"/>
-                      <a:tailEnd type="none" w="med" len="med"/>
-                    </a:lnT>
-                    <a:lnB w="6350" cap="flat" cmpd="sng" algn="ctr">
-                      <a:solidFill>
-                        <a:srgbClr val="D6E4EC"/>
-                      </a:solidFill>
-                      <a:prstDash val="solid"/>
-                      <a:round/>
-                      <a:headEnd type="none" w="med" len="med"/>
-                      <a:tailEnd type="none" w="med" len="med"/>
-                    </a:lnB>
-                    <a:solidFill>
-                      <a:srgbClr val="FFFFFF"/>
-                    </a:solidFill>
-                  </a:tcPr>
-                </a:tc>
-              </a:tr>
-              <a:tr h="310896">
-                <a:tc>
-                  <a:txBody>
-                    <a:bodyPr/>
-                    <a:lstStyle/>
-                    <a:p>
-                      <a:pPr indent="0" marL="0">
-                        <a:buNone/>
-                      </a:pPr>
-                      <a:r>
-                        <a:rPr lang="en-US" sz="850" dirty="0">
-                          <a:solidFill>
-                            <a:srgbClr val="13213A"/>
-                          </a:solidFill>
-                          <a:latin typeface="Microsoft YaHei" pitchFamily="34" charset="0"/>
-                          <a:ea typeface="Microsoft YaHei" pitchFamily="34" charset="-122"/>
-                          <a:cs typeface="Microsoft YaHei" pitchFamily="34" charset="-120"/>
-                        </a:rPr>
-                        <a:t>判卷</a:t>
-                      </a:r>
-                      <a:endParaRPr lang="en-US" sz="850" dirty="0">
-                        <a:latin typeface="Microsoft YaHei" charset="0"/>
-                        <a:ea typeface="Microsoft YaHei" charset="0"/>
-                        <a:cs typeface="Microsoft YaHei" charset="0"/>
-                      </a:endParaRPr>
-                    </a:p>
-                  </a:txBody>
-                  <a:tcPr marL="91440" marR="91440" marT="45720" marB="45720" anchor="ctr">
-                    <a:lnL w="6350" cap="flat" cmpd="sng" algn="ctr">
-                      <a:solidFill>
-                        <a:srgbClr val="D6E4EC"/>
-                      </a:solidFill>
-                      <a:prstDash val="solid"/>
-                      <a:round/>
-                      <a:headEnd type="none" w="med" len="med"/>
-                      <a:tailEnd type="none" w="med" len="med"/>
-                    </a:lnL>
-                    <a:lnR w="6350" cap="flat" cmpd="sng" algn="ctr">
-                      <a:solidFill>
-                        <a:srgbClr val="D6E4EC"/>
-                      </a:solidFill>
-                      <a:prstDash val="solid"/>
-                      <a:round/>
-                      <a:headEnd type="none" w="med" len="med"/>
-                      <a:tailEnd type="none" w="med" len="med"/>
-                    </a:lnR>
-                    <a:lnT w="6350" cap="flat" cmpd="sng" algn="ctr">
-                      <a:solidFill>
-                        <a:srgbClr val="D6E4EC"/>
-                      </a:solidFill>
-                      <a:prstDash val="solid"/>
-                      <a:round/>
-                      <a:headEnd type="none" w="med" len="med"/>
-                      <a:tailEnd type="none" w="med" len="med"/>
-                    </a:lnT>
-                    <a:lnB w="6350" cap="flat" cmpd="sng" algn="ctr">
-                      <a:solidFill>
-                        <a:srgbClr val="D6E4EC"/>
-                      </a:solidFill>
-                      <a:prstDash val="solid"/>
-                      <a:round/>
-                      <a:headEnd type="none" w="med" len="med"/>
-                      <a:tailEnd type="none" w="med" len="med"/>
-                    </a:lnB>
-                    <a:solidFill>
-                      <a:srgbClr val="FFFFFF"/>
-                    </a:solidFill>
-                  </a:tcPr>
-                </a:tc>
-                <a:tc>
-                  <a:txBody>
-                    <a:bodyPr/>
-                    <a:lstStyle/>
-                    <a:p>
-                      <a:pPr indent="0" marL="0">
-                        <a:buNone/>
-                      </a:pPr>
-                      <a:r>
-                        <a:rPr lang="en-US" sz="850" b="1" dirty="0">
-                          <a:solidFill>
-                            <a:srgbClr val="0FA8C9"/>
-                          </a:solidFill>
-                          <a:latin typeface="Microsoft YaHei" pitchFamily="34" charset="0"/>
-                          <a:ea typeface="Microsoft YaHei" pitchFamily="34" charset="-122"/>
-                          <a:cs typeface="Microsoft YaHei" pitchFamily="34" charset="-120"/>
-                        </a:rPr>
-                        <a:t>同一条评估流水线、同一个留出集</a:t>
-                      </a:r>
-                      <a:endParaRPr lang="en-US" sz="850" dirty="0">
-                        <a:latin typeface="Microsoft YaHei" charset="0"/>
-                        <a:ea typeface="Microsoft YaHei" charset="0"/>
-                        <a:cs typeface="Microsoft YaHei" charset="0"/>
-                      </a:endParaRPr>
-                    </a:p>
-                  </a:txBody>
-                  <a:tcPr marL="91440" marR="91440" marT="45720" marB="45720" anchor="ctr">
-                    <a:lnL w="6350" cap="flat" cmpd="sng" algn="ctr">
-                      <a:solidFill>
-                        <a:srgbClr val="D6E4EC"/>
-                      </a:solidFill>
-                      <a:prstDash val="solid"/>
-                      <a:round/>
-                      <a:headEnd type="none" w="med" len="med"/>
-                      <a:tailEnd type="none" w="med" len="med"/>
-                    </a:lnL>
-                    <a:lnR w="6350" cap="flat" cmpd="sng" algn="ctr">
-                      <a:solidFill>
-                        <a:srgbClr val="D6E4EC"/>
-                      </a:solidFill>
-                      <a:prstDash val="solid"/>
-                      <a:round/>
-                      <a:headEnd type="none" w="med" len="med"/>
-                      <a:tailEnd type="none" w="med" len="med"/>
-                    </a:lnR>
-                    <a:lnT w="6350" cap="flat" cmpd="sng" algn="ctr">
-                      <a:solidFill>
-                        <a:srgbClr val="D6E4EC"/>
-                      </a:solidFill>
-                      <a:prstDash val="solid"/>
-                      <a:round/>
-                      <a:headEnd type="none" w="med" len="med"/>
-                      <a:tailEnd type="none" w="med" len="med"/>
-                    </a:lnT>
-                    <a:lnB w="6350" cap="flat" cmpd="sng" algn="ctr">
-                      <a:solidFill>
-                        <a:srgbClr val="D6E4EC"/>
-                      </a:solidFill>
-                      <a:prstDash val="solid"/>
-                      <a:round/>
-                      <a:headEnd type="none" w="med" len="med"/>
-                      <a:tailEnd type="none" w="med" len="med"/>
-                    </a:lnB>
-                    <a:solidFill>
-                      <a:srgbClr val="FFFFFF"/>
-                    </a:solidFill>
-                  </a:tcPr>
-                </a:tc>
-                <a:tc>
-                  <a:txBody>
-                    <a:bodyPr/>
-                    <a:lstStyle/>
-                    <a:p>
-                      <a:pPr indent="0" marL="0">
-                        <a:buNone/>
-                      </a:pPr>
-                      <a:r>
-                        <a:rPr lang="en-US" sz="850" dirty="0">
-                          <a:solidFill>
-                            <a:srgbClr val="0FA8C9"/>
-                          </a:solidFill>
-                          <a:latin typeface="Microsoft YaHei" pitchFamily="34" charset="0"/>
-                          <a:ea typeface="Microsoft YaHei" pitchFamily="34" charset="-122"/>
-                          <a:cs typeface="Microsoft YaHei" pitchFamily="34" charset="-120"/>
-                        </a:rPr>
-                        <a:t>同左</a:t>
-                      </a:r>
-                      <a:endParaRPr lang="en-US" sz="850" dirty="0">
-                        <a:latin typeface="Microsoft YaHei" charset="0"/>
-                        <a:ea typeface="Microsoft YaHei" charset="0"/>
-                        <a:cs typeface="Microsoft YaHei" charset="0"/>
-                      </a:endParaRPr>
-                    </a:p>
-                  </a:txBody>
-                  <a:tcPr marL="91440" marR="91440" marT="45720" marB="45720" anchor="ctr">
-                    <a:lnL w="6350" cap="flat" cmpd="sng" algn="ctr">
-                      <a:solidFill>
-                        <a:srgbClr val="D6E4EC"/>
-                      </a:solidFill>
-                      <a:prstDash val="solid"/>
-                      <a:round/>
-                      <a:headEnd type="none" w="med" len="med"/>
-                      <a:tailEnd type="none" w="med" len="med"/>
-                    </a:lnL>
-                    <a:lnR w="6350" cap="flat" cmpd="sng" algn="ctr">
-                      <a:solidFill>
-                        <a:srgbClr val="D6E4EC"/>
-                      </a:solidFill>
-                      <a:prstDash val="solid"/>
-                      <a:round/>
-                      <a:headEnd type="none" w="med" len="med"/>
-                      <a:tailEnd type="none" w="med" len="med"/>
-                    </a:lnR>
-                    <a:lnT w="6350" cap="flat" cmpd="sng" algn="ctr">
-                      <a:solidFill>
-                        <a:srgbClr val="D6E4EC"/>
-                      </a:solidFill>
-                      <a:prstDash val="solid"/>
-                      <a:round/>
-                      <a:headEnd type="none" w="med" len="med"/>
-                      <a:tailEnd type="none" w="med" len="med"/>
-                    </a:lnT>
-                    <a:lnB w="6350" cap="flat" cmpd="sng" algn="ctr">
-                      <a:solidFill>
-                        <a:srgbClr val="D6E4EC"/>
-                      </a:solidFill>
-                      <a:prstDash val="solid"/>
-                      <a:round/>
-                      <a:headEnd type="none" w="med" len="med"/>
-                      <a:tailEnd type="none" w="med" len="med"/>
-                    </a:lnB>
-                    <a:solidFill>
-                      <a:srgbClr val="FFFFFF"/>
-                    </a:solidFill>
-                  </a:tcPr>
-                </a:tc>
-              </a:tr>
-            </a:tbl>
-          </a:graphicData>
-        </a:graphic>
-      </p:graphicFrame>
     </p:spTree>
   </p:cSld>
   <p:clrMapOvr>
@@ -9556,49 +7287,64 @@
           </a:p>
         </p:txBody>
       </p:sp>
-      <p:graphicFrame>
-        <p:nvGraphicFramePr>
-          <p:cNvPr id="5" name="Chart 0" descr=""/>
-          <p:cNvGraphicFramePr/>
-          <p:nvPr/>
-        </p:nvGraphicFramePr>
-        <p:xfrm>
-          <a:off x="457200" y="1417320"/>
-          <a:ext cx="5120640" cy="3108960"/>
-        </p:xfrm>
-        <a:graphic xmlns:a="http://schemas.openxmlformats.org/drawingml/2006/main">
-          <a:graphicData uri="http://schemas.openxmlformats.org/drawingml/2006/chart">
-            <c:chart xmlns:c="http://schemas.openxmlformats.org/drawingml/2006/chart" r:id="rId1"/>
-          </a:graphicData>
-        </a:graphic>
-      </p:graphicFrame>
-      <p:sp>
-        <p:nvSpPr>
-          <p:cNvPr id="6" name="Shape 3"/>
-          <p:cNvSpPr/>
-          <p:nvPr/>
-        </p:nvSpPr>
-        <p:spPr>
-          <a:xfrm>
-            <a:off x="5852160" y="1417320"/>
-            <a:ext cx="1371600" cy="1417320"/>
+      <p:sp>
+        <p:nvSpPr>
+          <p:cNvPr id="5" name="Shape 3"/>
+          <p:cNvSpPr/>
+          <p:nvPr/>
+        </p:nvSpPr>
+        <p:spPr>
+          <a:xfrm>
+            <a:off x="402336" y="1362456"/>
+            <a:ext cx="4312690" cy="3172968"/>
           </a:xfrm>
           <a:prstGeom prst="roundRect">
             <a:avLst>
-              <a:gd name="adj" fmla="val 8000"/>
+              <a:gd name="adj" fmla="val 2305"/>
             </a:avLst>
           </a:prstGeom>
           <a:solidFill>
             <a:srgbClr val="13213A"/>
           </a:solidFill>
-          <a:ln w="12700">
-            <a:solidFill>
-              <a:srgbClr val="13213A"/>
-            </a:solidFill>
-            <a:prstDash val="solid"/>
-          </a:ln>
-        </p:spPr>
-      </p:sp>
+          <a:ln w="9525">
+            <a:solidFill>
+              <a:srgbClr val="2A3F5F"/>
+            </a:solidFill>
+            <a:prstDash val="solid"/>
+          </a:ln>
+          <a:effectLst>
+            <a:outerShdw sx="100000" sy="100000" kx="0" ky="0" algn="bl" rotWithShape="0" blurRad="76200" dist="25400" dir="5400000">
+              <a:srgbClr val="000000">
+                <a:alpha val="35000"/>
+              </a:srgbClr>
+            </a:outerShdw>
+          </a:effectLst>
+        </p:spPr>
+      </p:sp>
+      <p:pic>
+        <p:nvPicPr>
+          <p:cNvPr id="6" name="Image 0" descr="preencoded.png">    </p:cNvPr>
+          <p:cNvPicPr>
+            <a:picLocks noChangeAspect="1"/>
+          </p:cNvPicPr>
+          <p:nvPr/>
+        </p:nvPicPr>
+        <p:blipFill>
+          <a:blip r:embed="rId1"/>
+          <a:stretch>
+            <a:fillRect/>
+          </a:stretch>
+        </p:blipFill>
+        <p:spPr>
+          <a:xfrm>
+            <a:off x="457200" y="1417320"/>
+            <a:ext cx="4202962" cy="3063240"/>
+          </a:xfrm>
+          <a:prstGeom prst="rect">
+            <a:avLst/>
+          </a:prstGeom>
+        </p:spPr>
+      </p:pic>
       <p:sp>
         <p:nvSpPr>
           <p:cNvPr id="7" name="Text 4"/>
@@ -9607,8 +7353,8 @@
         </p:nvSpPr>
         <p:spPr>
           <a:xfrm>
-            <a:off x="5961888" y="1554480"/>
-            <a:ext cx="1188720" cy="411480"/>
+            <a:off x="457200" y="4544568"/>
+            <a:ext cx="4202962" cy="274320"/>
           </a:xfrm>
           <a:prstGeom prst="rect">
             <a:avLst/>
@@ -9624,7 +7370,73 @@
               <a:buNone/>
             </a:pPr>
             <a:r>
-              <a:rPr lang="en-US" sz="1300" b="1" dirty="0">
+              <a:rPr lang="en-US" sz="850" i="1" dirty="0">
+                <a:solidFill>
+                  <a:srgbClr val="6B7A90"/>
+                </a:solidFill>
+                <a:latin typeface="Microsoft YaHei" pitchFamily="34" charset="0"/>
+                <a:ea typeface="Microsoft YaHei" pitchFamily="34" charset="-122"/>
+                <a:cs typeface="Microsoft YaHei" pitchFamily="34" charset="-120"/>
+              </a:rPr>
+              <a:t>真实回测：Top-5 组合 +69% vs 基准 +90%，夏普 1.03</a:t>
+            </a:r>
+            <a:endParaRPr lang="en-US" sz="850" dirty="0"/>
+          </a:p>
+        </p:txBody>
+      </p:sp>
+      <p:sp>
+        <p:nvSpPr>
+          <p:cNvPr id="8" name="Shape 5"/>
+          <p:cNvSpPr/>
+          <p:nvPr/>
+        </p:nvSpPr>
+        <p:spPr>
+          <a:xfrm>
+            <a:off x="4892040" y="1417320"/>
+            <a:ext cx="1828800" cy="1417320"/>
+          </a:xfrm>
+          <a:prstGeom prst="roundRect">
+            <a:avLst>
+              <a:gd name="adj" fmla="val 7742"/>
+            </a:avLst>
+          </a:prstGeom>
+          <a:solidFill>
+            <a:srgbClr val="13213A"/>
+          </a:solidFill>
+          <a:ln w="12700">
+            <a:solidFill>
+              <a:srgbClr val="13213A"/>
+            </a:solidFill>
+            <a:prstDash val="solid"/>
+          </a:ln>
+        </p:spPr>
+      </p:sp>
+      <p:sp>
+        <p:nvSpPr>
+          <p:cNvPr id="9" name="Text 6"/>
+          <p:cNvSpPr txBox="1"/>
+          <p:nvPr/>
+        </p:nvSpPr>
+        <p:spPr>
+          <a:xfrm>
+            <a:off x="5029200" y="1554480"/>
+            <a:ext cx="1600200" cy="411480"/>
+          </a:xfrm>
+          <a:prstGeom prst="rect">
+            <a:avLst/>
+          </a:prstGeom>
+          <a:noFill/>
+          <a:ln/>
+        </p:spPr>
+        <p:txBody>
+          <a:bodyPr wrap="square" lIns="0" tIns="0" rIns="0" bIns="0" rtlCol="0" anchor="ctr"/>
+          <a:lstStyle/>
+          <a:p>
+            <a:pPr indent="0" marL="0">
+              <a:buNone/>
+            </a:pPr>
+            <a:r>
+              <a:rPr lang="en-US" sz="1400" b="1" dirty="0">
                 <a:solidFill>
                   <a:srgbClr val="3BE0FF"/>
                 </a:solidFill>
@@ -9634,20 +7446,20 @@
               </a:rPr>
               <a:t>累计收益</a:t>
             </a:r>
-            <a:endParaRPr lang="en-US" sz="1300" dirty="0"/>
+            <a:endParaRPr lang="en-US" sz="1400" dirty="0"/>
           </a:p>
         </p:txBody>
       </p:sp>
       <p:sp>
         <p:nvSpPr>
-          <p:cNvPr id="8" name="Text 5"/>
+          <p:cNvPr id="10" name="Text 7"/>
           <p:cNvSpPr txBox="1"/>
           <p:nvPr/>
         </p:nvSpPr>
         <p:spPr>
           <a:xfrm>
-            <a:off x="5961888" y="1984248"/>
-            <a:ext cx="1188720" cy="777240"/>
+            <a:off x="5029200" y="1984248"/>
+            <a:ext cx="1600200" cy="777240"/>
           </a:xfrm>
           <a:prstGeom prst="rect">
             <a:avLst/>
@@ -9663,7 +7475,7 @@
               <a:buNone/>
             </a:pPr>
             <a:r>
-              <a:rPr lang="en-US" sz="950" dirty="0">
+              <a:rPr lang="en-US" sz="1000" dirty="0">
                 <a:solidFill>
                   <a:srgbClr val="DCE7F2"/>
                 </a:solidFill>
@@ -9673,24 +7485,24 @@
               </a:rPr>
               <a:t>一定和基准放在一起看</a:t>
             </a:r>
-            <a:endParaRPr lang="en-US" sz="950" dirty="0"/>
+            <a:endParaRPr lang="en-US" sz="1000" dirty="0"/>
           </a:p>
         </p:txBody>
       </p:sp>
       <p:sp>
         <p:nvSpPr>
-          <p:cNvPr id="9" name="Shape 6"/>
-          <p:cNvSpPr/>
-          <p:nvPr/>
-        </p:nvSpPr>
-        <p:spPr>
-          <a:xfrm>
-            <a:off x="7315200" y="1417320"/>
-            <a:ext cx="1371600" cy="1417320"/>
+          <p:cNvPr id="11" name="Shape 8"/>
+          <p:cNvSpPr/>
+          <p:nvPr/>
+        </p:nvSpPr>
+        <p:spPr>
+          <a:xfrm>
+            <a:off x="6858000" y="1417320"/>
+            <a:ext cx="1828800" cy="1417320"/>
           </a:xfrm>
           <a:prstGeom prst="roundRect">
             <a:avLst>
-              <a:gd name="adj" fmla="val 8000"/>
+              <a:gd name="adj" fmla="val 7742"/>
             </a:avLst>
           </a:prstGeom>
           <a:solidFill>
@@ -9706,14 +7518,14 @@
       </p:sp>
       <p:sp>
         <p:nvSpPr>
-          <p:cNvPr id="10" name="Text 7"/>
+          <p:cNvPr id="12" name="Text 9"/>
           <p:cNvSpPr txBox="1"/>
           <p:nvPr/>
         </p:nvSpPr>
         <p:spPr>
           <a:xfrm>
-            <a:off x="7424928" y="1554480"/>
-            <a:ext cx="1188720" cy="411480"/>
+            <a:off x="6995160" y="1554480"/>
+            <a:ext cx="1600200" cy="411480"/>
           </a:xfrm>
           <a:prstGeom prst="rect">
             <a:avLst/>
@@ -9729,7 +7541,7 @@
               <a:buNone/>
             </a:pPr>
             <a:r>
-              <a:rPr lang="en-US" sz="1300" b="1" dirty="0">
+              <a:rPr lang="en-US" sz="1400" b="1" dirty="0">
                 <a:solidFill>
                   <a:srgbClr val="3BE0FF"/>
                 </a:solidFill>
@@ -9739,20 +7551,20 @@
               </a:rPr>
               <a:t>年化收益</a:t>
             </a:r>
-            <a:endParaRPr lang="en-US" sz="1300" dirty="0"/>
+            <a:endParaRPr lang="en-US" sz="1400" dirty="0"/>
           </a:p>
         </p:txBody>
       </p:sp>
       <p:sp>
         <p:nvSpPr>
-          <p:cNvPr id="11" name="Text 8"/>
+          <p:cNvPr id="13" name="Text 10"/>
           <p:cNvSpPr txBox="1"/>
           <p:nvPr/>
         </p:nvSpPr>
         <p:spPr>
           <a:xfrm>
-            <a:off x="7424928" y="1984248"/>
-            <a:ext cx="1188720" cy="777240"/>
+            <a:off x="6995160" y="1984248"/>
+            <a:ext cx="1600200" cy="777240"/>
           </a:xfrm>
           <a:prstGeom prst="rect">
             <a:avLst/>
@@ -9768,7 +7580,7 @@
               <a:buNone/>
             </a:pPr>
             <a:r>
-              <a:rPr lang="en-US" sz="950" dirty="0">
+              <a:rPr lang="en-US" sz="1000" dirty="0">
                 <a:solidFill>
                   <a:srgbClr val="DCE7F2"/>
                 </a:solidFill>
@@ -9778,24 +7590,24 @@
               </a:rPr>
               <a:t>便于跨不同长度比较</a:t>
             </a:r>
-            <a:endParaRPr lang="en-US" sz="950" dirty="0"/>
+            <a:endParaRPr lang="en-US" sz="1000" dirty="0"/>
           </a:p>
         </p:txBody>
       </p:sp>
       <p:sp>
         <p:nvSpPr>
-          <p:cNvPr id="12" name="Shape 9"/>
-          <p:cNvSpPr/>
-          <p:nvPr/>
-        </p:nvSpPr>
-        <p:spPr>
-          <a:xfrm>
-            <a:off x="5852160" y="2971800"/>
-            <a:ext cx="1371600" cy="1417320"/>
+          <p:cNvPr id="14" name="Shape 11"/>
+          <p:cNvSpPr/>
+          <p:nvPr/>
+        </p:nvSpPr>
+        <p:spPr>
+          <a:xfrm>
+            <a:off x="4892040" y="2971800"/>
+            <a:ext cx="1828800" cy="1417320"/>
           </a:xfrm>
           <a:prstGeom prst="roundRect">
             <a:avLst>
-              <a:gd name="adj" fmla="val 8000"/>
+              <a:gd name="adj" fmla="val 7742"/>
             </a:avLst>
           </a:prstGeom>
           <a:solidFill>
@@ -9811,14 +7623,14 @@
       </p:sp>
       <p:sp>
         <p:nvSpPr>
-          <p:cNvPr id="13" name="Text 10"/>
+          <p:cNvPr id="15" name="Text 12"/>
           <p:cNvSpPr txBox="1"/>
           <p:nvPr/>
         </p:nvSpPr>
         <p:spPr>
           <a:xfrm>
-            <a:off x="5961888" y="3108960"/>
-            <a:ext cx="1188720" cy="411480"/>
+            <a:off x="5029200" y="3108960"/>
+            <a:ext cx="1600200" cy="411480"/>
           </a:xfrm>
           <a:prstGeom prst="rect">
             <a:avLst/>
@@ -9834,7 +7646,7 @@
               <a:buNone/>
             </a:pPr>
             <a:r>
-              <a:rPr lang="en-US" sz="1300" b="1" dirty="0">
+              <a:rPr lang="en-US" sz="1400" b="1" dirty="0">
                 <a:solidFill>
                   <a:srgbClr val="3BE0FF"/>
                 </a:solidFill>
@@ -9844,20 +7656,20 @@
               </a:rPr>
               <a:t>夏普比率</a:t>
             </a:r>
-            <a:endParaRPr lang="en-US" sz="1300" dirty="0"/>
+            <a:endParaRPr lang="en-US" sz="1400" dirty="0"/>
           </a:p>
         </p:txBody>
       </p:sp>
       <p:sp>
         <p:nvSpPr>
-          <p:cNvPr id="14" name="Text 11"/>
+          <p:cNvPr id="16" name="Text 13"/>
           <p:cNvSpPr txBox="1"/>
           <p:nvPr/>
         </p:nvSpPr>
         <p:spPr>
           <a:xfrm>
-            <a:off x="5961888" y="3538728"/>
-            <a:ext cx="1188720" cy="777240"/>
+            <a:off x="5029200" y="3538728"/>
+            <a:ext cx="1600200" cy="777240"/>
           </a:xfrm>
           <a:prstGeom prst="rect">
             <a:avLst/>
@@ -9873,7 +7685,7 @@
               <a:buNone/>
             </a:pPr>
             <a:r>
-              <a:rPr lang="en-US" sz="950" dirty="0">
+              <a:rPr lang="en-US" sz="1000" dirty="0">
                 <a:solidFill>
                   <a:srgbClr val="DCE7F2"/>
                 </a:solidFill>
@@ -9883,24 +7695,24 @@
               </a:rPr>
               <a:t>1 以上不错，2 以上警惕过拟合</a:t>
             </a:r>
-            <a:endParaRPr lang="en-US" sz="950" dirty="0"/>
+            <a:endParaRPr lang="en-US" sz="1000" dirty="0"/>
           </a:p>
         </p:txBody>
       </p:sp>
       <p:sp>
         <p:nvSpPr>
-          <p:cNvPr id="15" name="Shape 12"/>
-          <p:cNvSpPr/>
-          <p:nvPr/>
-        </p:nvSpPr>
-        <p:spPr>
-          <a:xfrm>
-            <a:off x="7315200" y="2971800"/>
-            <a:ext cx="1371600" cy="1417320"/>
+          <p:cNvPr id="17" name="Shape 14"/>
+          <p:cNvSpPr/>
+          <p:nvPr/>
+        </p:nvSpPr>
+        <p:spPr>
+          <a:xfrm>
+            <a:off x="6858000" y="2971800"/>
+            <a:ext cx="1828800" cy="1417320"/>
           </a:xfrm>
           <a:prstGeom prst="roundRect">
             <a:avLst>
-              <a:gd name="adj" fmla="val 8000"/>
+              <a:gd name="adj" fmla="val 7742"/>
             </a:avLst>
           </a:prstGeom>
           <a:solidFill>
@@ -9916,14 +7728,14 @@
       </p:sp>
       <p:sp>
         <p:nvSpPr>
-          <p:cNvPr id="16" name="Text 13"/>
+          <p:cNvPr id="18" name="Text 15"/>
           <p:cNvSpPr txBox="1"/>
           <p:nvPr/>
         </p:nvSpPr>
         <p:spPr>
           <a:xfrm>
-            <a:off x="7424928" y="3108960"/>
-            <a:ext cx="1188720" cy="411480"/>
+            <a:off x="6995160" y="3108960"/>
+            <a:ext cx="1600200" cy="411480"/>
           </a:xfrm>
           <a:prstGeom prst="rect">
             <a:avLst/>
@@ -9939,7 +7751,7 @@
               <a:buNone/>
             </a:pPr>
             <a:r>
-              <a:rPr lang="en-US" sz="1300" b="1" dirty="0">
+              <a:rPr lang="en-US" sz="1400" b="1" dirty="0">
                 <a:solidFill>
                   <a:srgbClr val="3BE0FF"/>
                 </a:solidFill>
@@ -9949,20 +7761,20 @@
               </a:rPr>
               <a:t>最大回撤</a:t>
             </a:r>
-            <a:endParaRPr lang="en-US" sz="1300" dirty="0"/>
+            <a:endParaRPr lang="en-US" sz="1400" dirty="0"/>
           </a:p>
         </p:txBody>
       </p:sp>
       <p:sp>
         <p:nvSpPr>
-          <p:cNvPr id="17" name="Text 14"/>
+          <p:cNvPr id="19" name="Text 16"/>
           <p:cNvSpPr txBox="1"/>
           <p:nvPr/>
         </p:nvSpPr>
         <p:spPr>
           <a:xfrm>
-            <a:off x="7424928" y="3538728"/>
-            <a:ext cx="1188720" cy="777240"/>
+            <a:off x="6995160" y="3538728"/>
+            <a:ext cx="1600200" cy="777240"/>
           </a:xfrm>
           <a:prstGeom prst="rect">
             <a:avLst/>
@@ -9978,7 +7790,7 @@
               <a:buNone/>
             </a:pPr>
             <a:r>
-              <a:rPr lang="en-US" sz="950" dirty="0">
+              <a:rPr lang="en-US" sz="1000" dirty="0">
                 <a:solidFill>
                   <a:srgbClr val="DCE7F2"/>
                 </a:solidFill>
@@ -9988,7 +7800,7 @@
               </a:rPr>
               <a:t>决定你能不能拿得住</a:t>
             </a:r>
-            <a:endParaRPr lang="en-US" sz="950" dirty="0"/>
+            <a:endParaRPr lang="en-US" sz="1000" dirty="0"/>
           </a:p>
         </p:txBody>
       </p:sp>
@@ -10134,32 +7946,74 @@
           </a:p>
         </p:txBody>
       </p:sp>
-      <p:graphicFrame>
-        <p:nvGraphicFramePr>
-          <p:cNvPr id="5" name="Chart 0" descr=""/>
-          <p:cNvGraphicFramePr/>
-          <p:nvPr/>
-        </p:nvGraphicFramePr>
-        <p:xfrm>
-          <a:off x="457200" y="1417320"/>
-          <a:ext cx="3931920" cy="2377440"/>
-        </p:xfrm>
-        <a:graphic xmlns:a="http://schemas.openxmlformats.org/drawingml/2006/main">
-          <a:graphicData uri="http://schemas.openxmlformats.org/drawingml/2006/chart">
-            <c:chart xmlns:c="http://schemas.openxmlformats.org/drawingml/2006/chart" r:id="rId1"/>
-          </a:graphicData>
-        </a:graphic>
-      </p:graphicFrame>
-      <p:sp>
-        <p:nvSpPr>
-          <p:cNvPr id="6" name="Text 3"/>
+      <p:sp>
+        <p:nvSpPr>
+          <p:cNvPr id="5" name="Shape 3"/>
+          <p:cNvSpPr/>
+          <p:nvPr/>
+        </p:nvSpPr>
+        <p:spPr>
+          <a:xfrm>
+            <a:off x="402336" y="1362456"/>
+            <a:ext cx="2583233" cy="3127248"/>
+          </a:xfrm>
+          <a:prstGeom prst="roundRect">
+            <a:avLst>
+              <a:gd name="adj" fmla="val 2832"/>
+            </a:avLst>
+          </a:prstGeom>
+          <a:solidFill>
+            <a:srgbClr val="13213A"/>
+          </a:solidFill>
+          <a:ln w="9525">
+            <a:solidFill>
+              <a:srgbClr val="2A3F5F"/>
+            </a:solidFill>
+            <a:prstDash val="solid"/>
+          </a:ln>
+          <a:effectLst>
+            <a:outerShdw sx="100000" sy="100000" kx="0" ky="0" algn="bl" rotWithShape="0" blurRad="76200" dist="25400" dir="5400000">
+              <a:srgbClr val="000000">
+                <a:alpha val="35000"/>
+              </a:srgbClr>
+            </a:outerShdw>
+          </a:effectLst>
+        </p:spPr>
+      </p:sp>
+      <p:pic>
+        <p:nvPicPr>
+          <p:cNvPr id="6" name="Image 0" descr="preencoded.png">    </p:cNvPr>
+          <p:cNvPicPr>
+            <a:picLocks noChangeAspect="1"/>
+          </p:cNvPicPr>
+          <p:nvPr/>
+        </p:nvPicPr>
+        <p:blipFill>
+          <a:blip r:embed="rId1"/>
+          <a:stretch>
+            <a:fillRect/>
+          </a:stretch>
+        </p:blipFill>
+        <p:spPr>
+          <a:xfrm>
+            <a:off x="457200" y="1417320"/>
+            <a:ext cx="2473505" cy="3017520"/>
+          </a:xfrm>
+          <a:prstGeom prst="rect">
+            <a:avLst/>
+          </a:prstGeom>
+        </p:spPr>
+      </p:pic>
+      <p:sp>
+        <p:nvSpPr>
+          <p:cNvPr id="7" name="Text 4"/>
           <p:cNvSpPr txBox="1"/>
           <p:nvPr/>
         </p:nvSpPr>
         <p:spPr>
           <a:xfrm>
-            <a:off x="457200" y="3886200"/>
-            <a:ext cx="3931920" cy="640080"/>
+            <a:off x="457200" y="4498848"/>
+            <a:ext cx="2473505" cy="274320"/>
           </a:xfrm>
           <a:prstGeom prst="rect">
             <a:avLst/>
@@ -10175,7 +8029,7 @@
               <a:buNone/>
             </a:pPr>
             <a:r>
-              <a:rPr lang="en-US" sz="1000" dirty="0">
+              <a:rPr lang="en-US" sz="850" i="1" dirty="0">
                 <a:solidFill>
                   <a:srgbClr val="6B7A90"/>
                 </a:solidFill>
@@ -10183,67 +8037,49 @@
                 <a:ea typeface="Microsoft YaHei" pitchFamily="34" charset="-122"/>
                 <a:cs typeface="Microsoft YaHei" pitchFamily="34" charset="-120"/>
               </a:rPr>
-              <a:t>网站「体检」还给出：五分层收益、换手与扣成本价差、4 段滚动 IC、牛熊分段、t 统计量，五项 A/B/C 评级。</a:t>
+              <a:t>「体检」报告：五项评级 + 分层 + IC 衰减</a:t>
             </a:r>
-            <a:endParaRPr lang="en-US" sz="1000" dirty="0"/>
+            <a:endParaRPr lang="en-US" sz="850" dirty="0"/>
           </a:p>
         </p:txBody>
       </p:sp>
       <p:sp>
         <p:nvSpPr>
-          <p:cNvPr id="7" name="Shape 4"/>
-          <p:cNvSpPr/>
-          <p:nvPr/>
-        </p:nvSpPr>
-        <p:spPr>
-          <a:xfrm>
-            <a:off x="4663440" y="1417320"/>
-            <a:ext cx="4023360" cy="1005840"/>
+          <p:cNvPr id="8" name="Shape 5"/>
+          <p:cNvSpPr/>
+          <p:nvPr/>
+        </p:nvSpPr>
+        <p:spPr>
+          <a:xfrm>
+            <a:off x="3191256" y="1362456"/>
+            <a:ext cx="3755768" cy="3127248"/>
           </a:xfrm>
           <a:prstGeom prst="roundRect">
             <a:avLst>
-              <a:gd name="adj" fmla="val 10909"/>
+              <a:gd name="adj" fmla="val 2339"/>
             </a:avLst>
           </a:prstGeom>
           <a:solidFill>
-            <a:srgbClr val="EEF6FA"/>
+            <a:srgbClr val="13213A"/>
           </a:solidFill>
           <a:ln w="9525">
             <a:solidFill>
-              <a:srgbClr val="D6E4EC"/>
-            </a:solidFill>
-            <a:prstDash val="solid"/>
-          </a:ln>
-        </p:spPr>
-      </p:sp>
-      <p:sp>
-        <p:nvSpPr>
-          <p:cNvPr id="8" name="Shape 5"/>
-          <p:cNvSpPr/>
-          <p:nvPr/>
-        </p:nvSpPr>
-        <p:spPr>
-          <a:xfrm>
-            <a:off x="4828032" y="1563624"/>
-            <a:ext cx="457200" cy="457200"/>
-          </a:xfrm>
-          <a:prstGeom prst="ellipse">
-            <a:avLst/>
-          </a:prstGeom>
-          <a:solidFill>
-            <a:srgbClr val="F0A500"/>
-          </a:solidFill>
-          <a:ln w="12700">
-            <a:solidFill>
-              <a:srgbClr val="F0A500"/>
-            </a:solidFill>
-            <a:prstDash val="solid"/>
-          </a:ln>
+              <a:srgbClr val="2A3F5F"/>
+            </a:solidFill>
+            <a:prstDash val="solid"/>
+          </a:ln>
+          <a:effectLst>
+            <a:outerShdw sx="100000" sy="100000" kx="0" ky="0" algn="bl" rotWithShape="0" blurRad="76200" dist="25400" dir="5400000">
+              <a:srgbClr val="000000">
+                <a:alpha val="35000"/>
+              </a:srgbClr>
+            </a:outerShdw>
+          </a:effectLst>
         </p:spPr>
       </p:sp>
       <p:pic>
         <p:nvPicPr>
-          <p:cNvPr id="9" name="Image 0" descr="preencoded.png">    </p:cNvPr>
+          <p:cNvPr id="9" name="Image 1" descr="preencoded.png">    </p:cNvPr>
           <p:cNvPicPr>
             <a:picLocks noChangeAspect="1"/>
           </p:cNvPicPr>
@@ -10257,8 +8093,8 @@
         </p:blipFill>
         <p:spPr>
           <a:xfrm>
-            <a:off x="4928616" y="1664208"/>
-            <a:ext cx="256032" cy="256032"/>
+            <a:off x="3246120" y="1417320"/>
+            <a:ext cx="3646040" cy="3017520"/>
           </a:xfrm>
           <a:prstGeom prst="rect">
             <a:avLst/>
@@ -10273,8 +8109,8 @@
         </p:nvSpPr>
         <p:spPr>
           <a:xfrm>
-            <a:off x="5394960" y="1581912"/>
-            <a:ext cx="3108960" cy="384048"/>
+            <a:off x="3246120" y="4498848"/>
+            <a:ext cx="3646040" cy="274320"/>
           </a:xfrm>
           <a:prstGeom prst="rect">
             <a:avLst/>
@@ -10290,7 +8126,122 @@
               <a:buNone/>
             </a:pPr>
             <a:r>
-              <a:rPr lang="en-US" sz="1400" b="1" dirty="0">
+              <a:rPr lang="en-US" sz="850" i="1" dirty="0">
+                <a:solidFill>
+                  <a:srgbClr val="6B7A90"/>
+                </a:solidFill>
+                <a:latin typeface="Microsoft YaHei" pitchFamily="34" charset="0"/>
+                <a:ea typeface="Microsoft YaHei" pitchFamily="34" charset="-122"/>
+                <a:cs typeface="Microsoft YaHei" pitchFamily="34" charset="-120"/>
+              </a:rPr>
+              <a:t>模拟持仓：上线后 vs 回测期，判定「边际增强」</a:t>
+            </a:r>
+            <a:endParaRPr lang="en-US" sz="850" dirty="0"/>
+          </a:p>
+        </p:txBody>
+      </p:sp>
+      <p:sp>
+        <p:nvSpPr>
+          <p:cNvPr id="11" name="Shape 7"/>
+          <p:cNvSpPr/>
+          <p:nvPr/>
+        </p:nvSpPr>
+        <p:spPr>
+          <a:xfrm>
+            <a:off x="5989320" y="1417320"/>
+            <a:ext cx="2697480" cy="1005840"/>
+          </a:xfrm>
+          <a:prstGeom prst="roundRect">
+            <a:avLst>
+              <a:gd name="adj" fmla="val 10909"/>
+            </a:avLst>
+          </a:prstGeom>
+          <a:solidFill>
+            <a:srgbClr val="EEF6FA"/>
+          </a:solidFill>
+          <a:ln w="9525">
+            <a:solidFill>
+              <a:srgbClr val="D6E4EC"/>
+            </a:solidFill>
+            <a:prstDash val="solid"/>
+          </a:ln>
+        </p:spPr>
+      </p:sp>
+      <p:sp>
+        <p:nvSpPr>
+          <p:cNvPr id="12" name="Shape 8"/>
+          <p:cNvSpPr/>
+          <p:nvPr/>
+        </p:nvSpPr>
+        <p:spPr>
+          <a:xfrm>
+            <a:off x="6099048" y="1508760"/>
+            <a:ext cx="329184" cy="329184"/>
+          </a:xfrm>
+          <a:prstGeom prst="ellipse">
+            <a:avLst/>
+          </a:prstGeom>
+          <a:solidFill>
+            <a:srgbClr val="F0A500"/>
+          </a:solidFill>
+          <a:ln w="12700">
+            <a:solidFill>
+              <a:srgbClr val="F0A500"/>
+            </a:solidFill>
+            <a:prstDash val="solid"/>
+          </a:ln>
+        </p:spPr>
+      </p:sp>
+      <p:pic>
+        <p:nvPicPr>
+          <p:cNvPr id="13" name="Image 2" descr="preencoded.png">    </p:cNvPr>
+          <p:cNvPicPr>
+            <a:picLocks noChangeAspect="1"/>
+          </p:cNvPicPr>
+          <p:nvPr/>
+        </p:nvPicPr>
+        <p:blipFill>
+          <a:blip r:embed="rId3"/>
+          <a:stretch>
+            <a:fillRect/>
+          </a:stretch>
+        </p:blipFill>
+        <p:spPr>
+          <a:xfrm>
+            <a:off x="6171468" y="1581180"/>
+            <a:ext cx="184343" cy="184343"/>
+          </a:xfrm>
+          <a:prstGeom prst="rect">
+            <a:avLst/>
+          </a:prstGeom>
+        </p:spPr>
+      </p:pic>
+      <p:sp>
+        <p:nvSpPr>
+          <p:cNvPr id="14" name="Text 9"/>
+          <p:cNvSpPr txBox="1"/>
+          <p:nvPr/>
+        </p:nvSpPr>
+        <p:spPr>
+          <a:xfrm>
+            <a:off x="6501384" y="1508760"/>
+            <a:ext cx="2093976" cy="329184"/>
+          </a:xfrm>
+          <a:prstGeom prst="rect">
+            <a:avLst/>
+          </a:prstGeom>
+          <a:noFill/>
+          <a:ln/>
+        </p:spPr>
+        <p:txBody>
+          <a:bodyPr wrap="square" lIns="0" tIns="0" rIns="0" bIns="0" rtlCol="0" anchor="ctr"/>
+          <a:lstStyle/>
+          <a:p>
+            <a:pPr indent="0" marL="0">
+              <a:buNone/>
+            </a:pPr>
+            <a:r>
+              <a:rPr lang="en-US" sz="1200" b="1" dirty="0">
                 <a:solidFill>
                   <a:srgbClr val="F0A500"/>
                 </a:solidFill>
@@ -10300,20 +8251,20 @@
               </a:rPr>
               <a:t>衰减检测</a:t>
             </a:r>
-            <a:endParaRPr lang="en-US" sz="1400" dirty="0"/>
+            <a:endParaRPr lang="en-US" sz="1200" dirty="0"/>
           </a:p>
         </p:txBody>
       </p:sp>
       <p:sp>
         <p:nvSpPr>
-          <p:cNvPr id="11" name="Text 7"/>
+          <p:cNvPr id="15" name="Text 10"/>
           <p:cNvSpPr txBox="1"/>
           <p:nvPr/>
         </p:nvSpPr>
         <p:spPr>
           <a:xfrm>
-            <a:off x="4846320" y="2057400"/>
-            <a:ext cx="3657600" cy="274320"/>
+            <a:off x="6126480" y="1874520"/>
+            <a:ext cx="2423160" cy="475488"/>
           </a:xfrm>
           <a:prstGeom prst="rect">
             <a:avLst/>
@@ -10329,7 +8280,7 @@
               <a:buNone/>
             </a:pPr>
             <a:r>
-              <a:rPr lang="en-US" sz="1100" dirty="0">
+              <a:rPr lang="en-US" sz="1000" dirty="0">
                 <a:solidFill>
                   <a:srgbClr val="13213A"/>
                 </a:solidFill>
@@ -10339,20 +8290,20 @@
               </a:rPr>
               <a:t>近 60 / 120 天 IC 明显低于全样本 = 钝了</a:t>
             </a:r>
-            <a:endParaRPr lang="en-US" sz="1100" dirty="0"/>
+            <a:endParaRPr lang="en-US" sz="1000" dirty="0"/>
           </a:p>
         </p:txBody>
       </p:sp>
       <p:sp>
         <p:nvSpPr>
-          <p:cNvPr id="12" name="Shape 8"/>
-          <p:cNvSpPr/>
-          <p:nvPr/>
-        </p:nvSpPr>
-        <p:spPr>
-          <a:xfrm>
-            <a:off x="4663440" y="2514600"/>
-            <a:ext cx="4023360" cy="1005840"/>
+          <p:cNvPr id="16" name="Shape 11"/>
+          <p:cNvSpPr/>
+          <p:nvPr/>
+        </p:nvSpPr>
+        <p:spPr>
+          <a:xfrm>
+            <a:off x="5989320" y="2514600"/>
+            <a:ext cx="2697480" cy="1005840"/>
           </a:xfrm>
           <a:prstGeom prst="roundRect">
             <a:avLst>
@@ -10372,14 +8323,14 @@
       </p:sp>
       <p:sp>
         <p:nvSpPr>
-          <p:cNvPr id="13" name="Shape 9"/>
-          <p:cNvSpPr/>
-          <p:nvPr/>
-        </p:nvSpPr>
-        <p:spPr>
-          <a:xfrm>
-            <a:off x="4828032" y="2660904"/>
-            <a:ext cx="457200" cy="457200"/>
+          <p:cNvPr id="17" name="Shape 12"/>
+          <p:cNvSpPr/>
+          <p:nvPr/>
+        </p:nvSpPr>
+        <p:spPr>
+          <a:xfrm>
+            <a:off x="6099048" y="2606040"/>
+            <a:ext cx="329184" cy="329184"/>
           </a:xfrm>
           <a:prstGeom prst="ellipse">
             <a:avLst/>
@@ -10397,22 +8348,22 @@
       </p:sp>
       <p:pic>
         <p:nvPicPr>
-          <p:cNvPr id="14" name="Image 1" descr="preencoded.png">    </p:cNvPr>
+          <p:cNvPr id="18" name="Image 3" descr="preencoded.png">    </p:cNvPr>
           <p:cNvPicPr>
             <a:picLocks noChangeAspect="1"/>
           </p:cNvPicPr>
           <p:nvPr/>
         </p:nvPicPr>
         <p:blipFill>
-          <a:blip r:embed="rId3"/>
+          <a:blip r:embed="rId4"/>
           <a:stretch>
             <a:fillRect/>
           </a:stretch>
         </p:blipFill>
         <p:spPr>
           <a:xfrm>
-            <a:off x="4928616" y="2761488"/>
-            <a:ext cx="256032" cy="256032"/>
+            <a:off x="6171468" y="2678460"/>
+            <a:ext cx="184343" cy="184343"/>
           </a:xfrm>
           <a:prstGeom prst="rect">
             <a:avLst/>
@@ -10421,14 +8372,14 @@
       </p:pic>
       <p:sp>
         <p:nvSpPr>
-          <p:cNvPr id="15" name="Text 10"/>
+          <p:cNvPr id="19" name="Text 13"/>
           <p:cNvSpPr txBox="1"/>
           <p:nvPr/>
         </p:nvSpPr>
         <p:spPr>
           <a:xfrm>
-            <a:off x="5394960" y="2679192"/>
-            <a:ext cx="3108960" cy="384048"/>
+            <a:off x="6501384" y="2606040"/>
+            <a:ext cx="2093976" cy="329184"/>
           </a:xfrm>
           <a:prstGeom prst="rect">
             <a:avLst/>
@@ -10444,7 +8395,7 @@
               <a:buNone/>
             </a:pPr>
             <a:r>
-              <a:rPr lang="en-US" sz="1400" b="1" dirty="0">
+              <a:rPr lang="en-US" sz="1200" b="1" dirty="0">
                 <a:solidFill>
                   <a:srgbClr val="1FA971"/>
                 </a:solidFill>
@@ -10454,20 +8405,20 @@
               </a:rPr>
               <a:t>跨市场移植</a:t>
             </a:r>
-            <a:endParaRPr lang="en-US" sz="1400" dirty="0"/>
+            <a:endParaRPr lang="en-US" sz="1200" dirty="0"/>
           </a:p>
         </p:txBody>
       </p:sp>
       <p:sp>
         <p:nvSpPr>
-          <p:cNvPr id="16" name="Text 11"/>
+          <p:cNvPr id="20" name="Text 14"/>
           <p:cNvSpPr txBox="1"/>
           <p:nvPr/>
         </p:nvSpPr>
         <p:spPr>
           <a:xfrm>
-            <a:off x="4846320" y="3154680"/>
-            <a:ext cx="3657600" cy="274320"/>
+            <a:off x="6126480" y="2971800"/>
+            <a:ext cx="2423160" cy="475488"/>
           </a:xfrm>
           <a:prstGeom prst="rect">
             <a:avLst/>
@@ -10483,7 +8434,7 @@
               <a:buNone/>
             </a:pPr>
             <a:r>
-              <a:rPr lang="en-US" sz="1100" dirty="0">
+              <a:rPr lang="en-US" sz="1000" dirty="0">
                 <a:solidFill>
                   <a:srgbClr val="13213A"/>
                 </a:solidFill>
@@ -10493,20 +8444,20 @@
               </a:rPr>
               <a:t>美股因子放到加密重算：两边都成立更像真规律</a:t>
             </a:r>
-            <a:endParaRPr lang="en-US" sz="1100" dirty="0"/>
+            <a:endParaRPr lang="en-US" sz="1000" dirty="0"/>
           </a:p>
         </p:txBody>
       </p:sp>
       <p:sp>
         <p:nvSpPr>
-          <p:cNvPr id="17" name="Shape 12"/>
-          <p:cNvSpPr/>
-          <p:nvPr/>
-        </p:nvSpPr>
-        <p:spPr>
-          <a:xfrm>
-            <a:off x="4663440" y="3611880"/>
-            <a:ext cx="4023360" cy="1005840"/>
+          <p:cNvPr id="21" name="Shape 15"/>
+          <p:cNvSpPr/>
+          <p:nvPr/>
+        </p:nvSpPr>
+        <p:spPr>
+          <a:xfrm>
+            <a:off x="5989320" y="3611880"/>
+            <a:ext cx="2697480" cy="1005840"/>
           </a:xfrm>
           <a:prstGeom prst="roundRect">
             <a:avLst>
@@ -10526,14 +8477,14 @@
       </p:sp>
       <p:sp>
         <p:nvSpPr>
-          <p:cNvPr id="18" name="Shape 13"/>
-          <p:cNvSpPr/>
-          <p:nvPr/>
-        </p:nvSpPr>
-        <p:spPr>
-          <a:xfrm>
-            <a:off x="4828032" y="3758184"/>
-            <a:ext cx="457200" cy="457200"/>
+          <p:cNvPr id="22" name="Shape 16"/>
+          <p:cNvSpPr/>
+          <p:nvPr/>
+        </p:nvSpPr>
+        <p:spPr>
+          <a:xfrm>
+            <a:off x="6099048" y="3703320"/>
+            <a:ext cx="329184" cy="329184"/>
           </a:xfrm>
           <a:prstGeom prst="ellipse">
             <a:avLst/>
@@ -10551,22 +8502,22 @@
       </p:sp>
       <p:pic>
         <p:nvPicPr>
-          <p:cNvPr id="19" name="Image 2" descr="preencoded.png">    </p:cNvPr>
+          <p:cNvPr id="23" name="Image 4" descr="preencoded.png">    </p:cNvPr>
           <p:cNvPicPr>
             <a:picLocks noChangeAspect="1"/>
           </p:cNvPicPr>
           <p:nvPr/>
         </p:nvPicPr>
         <p:blipFill>
-          <a:blip r:embed="rId4"/>
+          <a:blip r:embed="rId5"/>
           <a:stretch>
             <a:fillRect/>
           </a:stretch>
         </p:blipFill>
         <p:spPr>
           <a:xfrm>
-            <a:off x="4928616" y="3858768"/>
-            <a:ext cx="256032" cy="256032"/>
+            <a:off x="6171468" y="3775740"/>
+            <a:ext cx="184343" cy="184343"/>
           </a:xfrm>
           <a:prstGeom prst="rect">
             <a:avLst/>
@@ -10575,14 +8526,14 @@
       </p:pic>
       <p:sp>
         <p:nvSpPr>
-          <p:cNvPr id="20" name="Text 14"/>
+          <p:cNvPr id="24" name="Text 17"/>
           <p:cNvSpPr txBox="1"/>
           <p:nvPr/>
         </p:nvSpPr>
         <p:spPr>
           <a:xfrm>
-            <a:off x="5394960" y="3776472"/>
-            <a:ext cx="3108960" cy="384048"/>
+            <a:off x="6501384" y="3703320"/>
+            <a:ext cx="2093976" cy="329184"/>
           </a:xfrm>
           <a:prstGeom prst="rect">
             <a:avLst/>
@@ -10598,7 +8549,7 @@
               <a:buNone/>
             </a:pPr>
             <a:r>
-              <a:rPr lang="en-US" sz="1400" b="1" dirty="0">
+              <a:rPr lang="en-US" sz="1200" b="1" dirty="0">
                 <a:solidFill>
                   <a:srgbClr val="0FA8C9"/>
                 </a:solidFill>
@@ -10606,22 +8557,22 @@
                 <a:ea typeface="Microsoft YaHei" pitchFamily="34" charset="-122"/>
                 <a:cs typeface="Microsoft YaHei" pitchFamily="34" charset="-120"/>
               </a:rPr>
-              <a:t>前向跟踪（模拟持仓）</a:t>
+              <a:t>前向跟踪</a:t>
             </a:r>
-            <a:endParaRPr lang="en-US" sz="1400" dirty="0"/>
+            <a:endParaRPr lang="en-US" sz="1200" dirty="0"/>
           </a:p>
         </p:txBody>
       </p:sp>
       <p:sp>
         <p:nvSpPr>
-          <p:cNvPr id="21" name="Text 15"/>
+          <p:cNvPr id="25" name="Text 18"/>
           <p:cNvSpPr txBox="1"/>
           <p:nvPr/>
         </p:nvSpPr>
         <p:spPr>
           <a:xfrm>
-            <a:off x="4846320" y="4251960"/>
-            <a:ext cx="3657600" cy="274320"/>
+            <a:off x="6126480" y="4069080"/>
+            <a:ext cx="2423160" cy="475488"/>
           </a:xfrm>
           <a:prstGeom prst="rect">
             <a:avLst/>
@@ -10637,7 +8588,7 @@
               <a:buNone/>
             </a:pPr>
             <a:r>
-              <a:rPr lang="en-US" sz="1100" dirty="0">
+              <a:rPr lang="en-US" sz="1000" dirty="0">
                 <a:solidFill>
                   <a:srgbClr val="13213A"/>
                 </a:solidFill>
@@ -10647,7 +8598,7 @@
               </a:rPr>
               <a:t>上线前后夏普并排：保持 / 衰减 / 增强</a:t>
             </a:r>
-            <a:endParaRPr lang="en-US" sz="1100" dirty="0"/>
+            <a:endParaRPr lang="en-US" sz="1000" dirty="0"/>
           </a:p>
         </p:txBody>
       </p:sp>
@@ -21510,15 +19461,112 @@
         </p:nvSpPr>
         <p:spPr>
           <a:xfrm>
-            <a:off x="4663440" y="1463040"/>
-            <a:ext cx="4023360" cy="1417320"/>
+            <a:off x="4608576" y="1362456"/>
+            <a:ext cx="4133088" cy="989838"/>
           </a:xfrm>
           <a:prstGeom prst="roundRect">
             <a:avLst>
-              <a:gd name="adj" fmla="val 7742"/>
+              <a:gd name="adj" fmla="val 7390"/>
             </a:avLst>
           </a:prstGeom>
           <a:solidFill>
+            <a:srgbClr val="13213A"/>
+          </a:solidFill>
+          <a:ln w="9525">
+            <a:solidFill>
+              <a:srgbClr val="2A3F5F"/>
+            </a:solidFill>
+            <a:prstDash val="solid"/>
+          </a:ln>
+          <a:effectLst>
+            <a:outerShdw sx="100000" sy="100000" kx="0" ky="0" algn="bl" rotWithShape="0" blurRad="76200" dist="25400" dir="5400000">
+              <a:srgbClr val="000000">
+                <a:alpha val="35000"/>
+              </a:srgbClr>
+            </a:outerShdw>
+          </a:effectLst>
+        </p:spPr>
+      </p:sp>
+      <p:pic>
+        <p:nvPicPr>
+          <p:cNvPr id="20" name="Image 4" descr="preencoded.png">    </p:cNvPr>
+          <p:cNvPicPr>
+            <a:picLocks noChangeAspect="1"/>
+          </p:cNvPicPr>
+          <p:nvPr/>
+        </p:nvPicPr>
+        <p:blipFill>
+          <a:blip r:embed="rId5"/>
+          <a:stretch>
+            <a:fillRect/>
+          </a:stretch>
+        </p:blipFill>
+        <p:spPr>
+          <a:xfrm>
+            <a:off x="4663440" y="1417320"/>
+            <a:ext cx="4023360" cy="880110"/>
+          </a:xfrm>
+          <a:prstGeom prst="rect">
+            <a:avLst/>
+          </a:prstGeom>
+        </p:spPr>
+      </p:pic>
+      <p:sp>
+        <p:nvSpPr>
+          <p:cNvPr id="21" name="Text 14"/>
+          <p:cNvSpPr txBox="1"/>
+          <p:nvPr/>
+        </p:nvSpPr>
+        <p:spPr>
+          <a:xfrm>
+            <a:off x="4663440" y="2361438"/>
+            <a:ext cx="4023360" cy="274320"/>
+          </a:xfrm>
+          <a:prstGeom prst="rect">
+            <a:avLst/>
+          </a:prstGeom>
+          <a:noFill/>
+          <a:ln/>
+        </p:spPr>
+        <p:txBody>
+          <a:bodyPr wrap="square" lIns="0" tIns="0" rIns="0" bIns="0" rtlCol="0" anchor="ctr"/>
+          <a:lstStyle/>
+          <a:p>
+            <a:pPr indent="0" marL="0">
+              <a:buNone/>
+            </a:pPr>
+            <a:r>
+              <a:rPr lang="en-US" sz="850" i="1" dirty="0">
+                <a:solidFill>
+                  <a:srgbClr val="6B7A90"/>
+                </a:solidFill>
+                <a:latin typeface="Microsoft YaHei" pitchFamily="34" charset="0"/>
+                <a:ea typeface="Microsoft YaHei" pitchFamily="34" charset="-122"/>
+                <a:cs typeface="Microsoft YaHei" pitchFamily="34" charset="-120"/>
+              </a:rPr>
+              <a:t>网站「因子挖掘」板块：选市场、门槛、轮数后开始循环（真实截图）</a:t>
+            </a:r>
+            <a:endParaRPr lang="en-US" sz="850" dirty="0"/>
+          </a:p>
+        </p:txBody>
+      </p:sp>
+      <p:sp>
+        <p:nvSpPr>
+          <p:cNvPr id="22" name="Shape 15"/>
+          <p:cNvSpPr/>
+          <p:nvPr/>
+        </p:nvSpPr>
+        <p:spPr>
+          <a:xfrm>
+            <a:off x="4663440" y="3337560"/>
+            <a:ext cx="4023360" cy="1325880"/>
+          </a:xfrm>
+          <a:prstGeom prst="roundRect">
+            <a:avLst>
+              <a:gd name="adj" fmla="val 8276"/>
+            </a:avLst>
+          </a:prstGeom>
+          <a:solidFill>
             <a:srgbClr val="EEF6FA"/>
           </a:solidFill>
           <a:ln w="9525">
@@ -21531,13 +19579,13 @@
       </p:sp>
       <p:sp>
         <p:nvSpPr>
-          <p:cNvPr id="20" name="Text 14"/>
+          <p:cNvPr id="23" name="Text 16"/>
           <p:cNvSpPr txBox="1"/>
           <p:nvPr/>
         </p:nvSpPr>
         <p:spPr>
           <a:xfrm>
-            <a:off x="4846320" y="1627632"/>
+            <a:off x="4846320" y="3502152"/>
             <a:ext cx="3657600" cy="384048"/>
           </a:xfrm>
           <a:prstGeom prst="rect">
@@ -21556,13 +19604,13 @@
             <a:r>
               <a:rPr lang="en-US" sz="1400" b="1" dirty="0">
                 <a:solidFill>
-                  <a:srgbClr val="0FA8C9"/>
+                  <a:srgbClr val="7C5CFF"/>
                 </a:solidFill>
                 <a:latin typeface="Microsoft YaHei" pitchFamily="34" charset="0"/>
                 <a:ea typeface="Microsoft YaHei" pitchFamily="34" charset="-122"/>
                 <a:cs typeface="Microsoft YaHei" pitchFamily="34" charset="-120"/>
               </a:rPr>
-              <a:t>它不是「多聊几轮」</a:t>
+              <a:t>两句话</a:t>
             </a:r>
             <a:endParaRPr lang="en-US" sz="1400" dirty="0"/>
           </a:p>
@@ -21570,14 +19618,14 @@
       </p:sp>
       <p:sp>
         <p:nvSpPr>
-          <p:cNvPr id="21" name="Text 15"/>
+          <p:cNvPr id="24" name="Text 17"/>
           <p:cNvSpPr txBox="1"/>
           <p:nvPr/>
         </p:nvSpPr>
         <p:spPr>
           <a:xfrm>
-            <a:off x="4846320" y="2103120"/>
-            <a:ext cx="3657600" cy="685800"/>
+            <a:off x="4846320" y="3977640"/>
+            <a:ext cx="3657600" cy="594360"/>
           </a:xfrm>
           <a:prstGeom prst="rect">
             <a:avLst/>
@@ -21601,98 +19649,10 @@
                 <a:ea typeface="Microsoft YaHei" pitchFamily="34" charset="-122"/>
                 <a:cs typeface="Microsoft YaHei" pitchFamily="34" charset="-120"/>
               </a:rPr>
-              <a:t>每一轮结束后，成绩单和错题本原样进入下一轮题目。AI 变强不是因为想得更久，而是因为看到了上一轮哪些被接受、哪些被拒、为什么。</a:t>
+              <a:t>① 不是多聊几轮：成绩单和错题本原样进入下一轮。</a:t>
             </a:r>
             <a:endParaRPr lang="en-US" sz="1100" dirty="0"/>
           </a:p>
-        </p:txBody>
-      </p:sp>
-      <p:sp>
-        <p:nvSpPr>
-          <p:cNvPr id="22" name="Shape 16"/>
-          <p:cNvSpPr/>
-          <p:nvPr/>
-        </p:nvSpPr>
-        <p:spPr>
-          <a:xfrm>
-            <a:off x="4663440" y="3017520"/>
-            <a:ext cx="4023360" cy="1600200"/>
-          </a:xfrm>
-          <a:prstGeom prst="roundRect">
-            <a:avLst>
-              <a:gd name="adj" fmla="val 6857"/>
-            </a:avLst>
-          </a:prstGeom>
-          <a:solidFill>
-            <a:srgbClr val="EEF6FA"/>
-          </a:solidFill>
-          <a:ln w="9525">
-            <a:solidFill>
-              <a:srgbClr val="D6E4EC"/>
-            </a:solidFill>
-            <a:prstDash val="solid"/>
-          </a:ln>
-        </p:spPr>
-      </p:sp>
-      <p:sp>
-        <p:nvSpPr>
-          <p:cNvPr id="23" name="Text 17"/>
-          <p:cNvSpPr txBox="1"/>
-          <p:nvPr/>
-        </p:nvSpPr>
-        <p:spPr>
-          <a:xfrm>
-            <a:off x="4846320" y="3182112"/>
-            <a:ext cx="3657600" cy="384048"/>
-          </a:xfrm>
-          <a:prstGeom prst="rect">
-            <a:avLst/>
-          </a:prstGeom>
-          <a:noFill/>
-          <a:ln/>
-        </p:spPr>
-        <p:txBody>
-          <a:bodyPr wrap="square" lIns="0" tIns="0" rIns="0" bIns="0" rtlCol="0" anchor="ctr"/>
-          <a:lstStyle/>
-          <a:p>
-            <a:pPr indent="0" marL="0">
-              <a:buNone/>
-            </a:pPr>
-            <a:r>
-              <a:rPr lang="en-US" sz="1400" b="1" dirty="0">
-                <a:solidFill>
-                  <a:srgbClr val="7C5CFF"/>
-                </a:solidFill>
-                <a:latin typeface="Microsoft YaHei" pitchFamily="34" charset="0"/>
-                <a:ea typeface="Microsoft YaHei" pitchFamily="34" charset="-122"/>
-                <a:cs typeface="Microsoft YaHei" pitchFamily="34" charset="-120"/>
-              </a:rPr>
-              <a:t>打分的是程序，不是 AI</a:t>
-            </a:r>
-            <a:endParaRPr lang="en-US" sz="1400" dirty="0"/>
-          </a:p>
-        </p:txBody>
-      </p:sp>
-      <p:sp>
-        <p:nvSpPr>
-          <p:cNvPr id="24" name="Text 18"/>
-          <p:cNvSpPr txBox="1"/>
-          <p:nvPr/>
-        </p:nvSpPr>
-        <p:spPr>
-          <a:xfrm>
-            <a:off x="4846320" y="3657600"/>
-            <a:ext cx="3657600" cy="868680"/>
-          </a:xfrm>
-          <a:prstGeom prst="rect">
-            <a:avLst/>
-          </a:prstGeom>
-          <a:noFill/>
-          <a:ln/>
-        </p:spPr>
-        <p:txBody>
-          <a:bodyPr wrap="square" lIns="0" tIns="0" rIns="0" bIns="0" rtlCol="0" anchor="t"/>
-          <a:lstStyle/>
           <a:p>
             <a:pPr indent="0" marL="0">
               <a:buNone/>
@@ -21706,7 +19666,7 @@
                 <a:ea typeface="Microsoft YaHei" pitchFamily="34" charset="-122"/>
                 <a:cs typeface="Microsoft YaHei" pitchFamily="34" charset="-120"/>
               </a:rPr>
-              <a:t>评估器是确定性代码：校验语法 → 算 IC → 样本内、留出、重复度、成本逐项检查。AI 不能给自己的作业打分，这是整个循环可信的前提。</a:t>
+              <a:t>② 打分的是程序：语法→IC→留出→重复→成本逐项检查，AI 不给自己打分。</a:t>
             </a:r>
             <a:endParaRPr lang="en-US" sz="1100" dirty="0"/>
           </a:p>

</xml_diff>

<commit_message>
Docs: deck spacing fix
Co-Authored-By: Claude Fable 5.1 <noreply@anthropic.com>
</commit_message>
<xml_diff>
--- a/docs/lecture/因子挖掘-15分钟.pptx
+++ b/docs/lecture/因子挖掘-15分钟.pptx
@@ -19558,12 +19558,12 @@
         </p:nvSpPr>
         <p:spPr>
           <a:xfrm>
-            <a:off x="4663440" y="3337560"/>
-            <a:ext cx="4023360" cy="1325880"/>
+            <a:off x="4663440" y="3246120"/>
+            <a:ext cx="4023360" cy="1417320"/>
           </a:xfrm>
           <a:prstGeom prst="roundRect">
             <a:avLst>
-              <a:gd name="adj" fmla="val 8276"/>
+              <a:gd name="adj" fmla="val 7742"/>
             </a:avLst>
           </a:prstGeom>
           <a:solidFill>
@@ -19585,7 +19585,7 @@
         </p:nvSpPr>
         <p:spPr>
           <a:xfrm>
-            <a:off x="4846320" y="3502152"/>
+            <a:off x="4846320" y="3410712"/>
             <a:ext cx="3657600" cy="384048"/>
           </a:xfrm>
           <a:prstGeom prst="rect">
@@ -19624,8 +19624,8 @@
         </p:nvSpPr>
         <p:spPr>
           <a:xfrm>
-            <a:off x="4846320" y="3977640"/>
-            <a:ext cx="3657600" cy="594360"/>
+            <a:off x="4846320" y="3886200"/>
+            <a:ext cx="3657600" cy="685800"/>
           </a:xfrm>
           <a:prstGeom prst="rect">
             <a:avLst/>

</xml_diff>